<commit_message>
Update MARLET methodology and framework figure
</commit_message>
<xml_diff>
--- a/figures/pptx/marlet_framework_figure.pptx
+++ b/figures/pptx/marlet_framework_figure.pptx
@@ -4,10 +4,14 @@
   <p:sldMasterIdLst>
     <p:sldMasterId id="2147483648" r:id="rId1"/>
   </p:sldMasterIdLst>
+  <p:notesMasterIdLst>
+    <p:notesMasterId r:id="rId4"/>
+  </p:notesMasterIdLst>
   <p:sldIdLst>
-    <p:sldId id="256" r:id="rId7"/>
+    <p:sldId id="256" r:id="rId2"/>
+    <p:sldId id="257" r:id="rId3"/>
   </p:sldIdLst>
-  <p:sldSz cx="12191695" cy="6858000" type="screen4x3"/>
+  <p:sldSz cx="12192000" cy="6858000"/>
   <p:notesSz cx="6858000" cy="9144000"/>
   <p:defaultTextStyle>
     <a:defPPr>
@@ -104,7 +108,456 @@
       </a:defRPr>
     </a:lvl9pPr>
   </p:defaultTextStyle>
+  <p:extLst>
+    <p:ext uri="{EFAFB233-063F-42B5-8137-9DF3F51BA10A}">
+      <p15:sldGuideLst xmlns:p15="http://schemas.microsoft.com/office/powerpoint/2012/main">
+        <p15:guide id="1" orient="horz" pos="2160">
+          <p15:clr>
+            <a:srgbClr val="A4A3A4"/>
+          </p15:clr>
+        </p15:guide>
+        <p15:guide id="2" pos="2880">
+          <p15:clr>
+            <a:srgbClr val="A4A3A4"/>
+          </p15:clr>
+        </p15:guide>
+      </p15:sldGuideLst>
+    </p:ext>
+  </p:extLst>
 </p:presentation>
+</file>
+
+<file path=ppt/notesMasters/notesMaster1.xml><?xml version="1.0" encoding="utf-8"?>
+<p:notesMaster xmlns:a="http://schemas.openxmlformats.org/drawingml/2006/main" xmlns:r="http://schemas.openxmlformats.org/officeDocument/2006/relationships" xmlns:p="http://schemas.openxmlformats.org/presentationml/2006/main">
+  <p:cSld>
+    <p:bg>
+      <p:bgRef idx="1001">
+        <a:schemeClr val="bg1"/>
+      </p:bgRef>
+    </p:bg>
+    <p:spTree>
+      <p:nvGrpSpPr>
+        <p:cNvPr id="1" name=""/>
+        <p:cNvGrpSpPr/>
+        <p:nvPr/>
+      </p:nvGrpSpPr>
+      <p:grpSpPr>
+        <a:xfrm>
+          <a:off x="0" y="0"/>
+          <a:ext cx="0" cy="0"/>
+          <a:chOff x="0" y="0"/>
+          <a:chExt cx="0" cy="0"/>
+        </a:xfrm>
+      </p:grpSpPr>
+      <p:sp>
+        <p:nvSpPr>
+          <p:cNvPr id="2" name="Header Placeholder 1"/>
+          <p:cNvSpPr>
+            <a:spLocks noGrp="1"/>
+          </p:cNvSpPr>
+          <p:nvPr>
+            <p:ph type="hdr" sz="quarter"/>
+          </p:nvPr>
+        </p:nvSpPr>
+        <p:spPr>
+          <a:xfrm>
+            <a:off x="0" y="0"/>
+            <a:ext cx="2971800" cy="458788"/>
+          </a:xfrm>
+          <a:prstGeom prst="rect">
+            <a:avLst/>
+          </a:prstGeom>
+        </p:spPr>
+        <p:txBody>
+          <a:bodyPr vert="horz" lIns="91440" tIns="45720" rIns="91440" bIns="45720" rtlCol="0"/>
+          <a:lstStyle>
+            <a:lvl1pPr algn="l">
+              <a:defRPr sz="1200"/>
+            </a:lvl1pPr>
+          </a:lstStyle>
+          <a:p>
+            <a:endParaRPr lang="en-US"/>
+          </a:p>
+        </p:txBody>
+      </p:sp>
+      <p:sp>
+        <p:nvSpPr>
+          <p:cNvPr id="3" name="Date Placeholder 2"/>
+          <p:cNvSpPr>
+            <a:spLocks noGrp="1"/>
+          </p:cNvSpPr>
+          <p:nvPr>
+            <p:ph type="dt" idx="1"/>
+          </p:nvPr>
+        </p:nvSpPr>
+        <p:spPr>
+          <a:xfrm>
+            <a:off x="3884613" y="0"/>
+            <a:ext cx="2971800" cy="458788"/>
+          </a:xfrm>
+          <a:prstGeom prst="rect">
+            <a:avLst/>
+          </a:prstGeom>
+        </p:spPr>
+        <p:txBody>
+          <a:bodyPr vert="horz" lIns="91440" tIns="45720" rIns="91440" bIns="45720" rtlCol="0"/>
+          <a:lstStyle>
+            <a:lvl1pPr algn="r">
+              <a:defRPr sz="1200"/>
+            </a:lvl1pPr>
+          </a:lstStyle>
+          <a:p>
+            <a:fld id="{72D63E16-4C7C-A645-9EE0-BA068410D510}" type="datetimeFigureOut">
+              <a:rPr lang="en-US" smtClean="0"/>
+              <a:t>5/3/26</a:t>
+            </a:fld>
+            <a:endParaRPr lang="en-US"/>
+          </a:p>
+        </p:txBody>
+      </p:sp>
+      <p:sp>
+        <p:nvSpPr>
+          <p:cNvPr id="4" name="Slide Image Placeholder 3"/>
+          <p:cNvSpPr>
+            <a:spLocks noGrp="1" noRot="1" noChangeAspect="1"/>
+          </p:cNvSpPr>
+          <p:nvPr>
+            <p:ph type="sldImg" idx="2"/>
+          </p:nvPr>
+        </p:nvSpPr>
+        <p:spPr>
+          <a:xfrm>
+            <a:off x="685800" y="1143000"/>
+            <a:ext cx="5486400" cy="3086100"/>
+          </a:xfrm>
+          <a:prstGeom prst="rect">
+            <a:avLst/>
+          </a:prstGeom>
+          <a:noFill/>
+          <a:ln w="12700">
+            <a:solidFill>
+              <a:prstClr val="black"/>
+            </a:solidFill>
+          </a:ln>
+        </p:spPr>
+        <p:txBody>
+          <a:bodyPr vert="horz" lIns="91440" tIns="45720" rIns="91440" bIns="45720" rtlCol="0" anchor="ctr"/>
+          <a:lstStyle/>
+          <a:p>
+            <a:endParaRPr lang="en-US"/>
+          </a:p>
+        </p:txBody>
+      </p:sp>
+      <p:sp>
+        <p:nvSpPr>
+          <p:cNvPr id="5" name="Notes Placeholder 4"/>
+          <p:cNvSpPr>
+            <a:spLocks noGrp="1"/>
+          </p:cNvSpPr>
+          <p:nvPr>
+            <p:ph type="body" sz="quarter" idx="3"/>
+          </p:nvPr>
+        </p:nvSpPr>
+        <p:spPr>
+          <a:xfrm>
+            <a:off x="685800" y="4400550"/>
+            <a:ext cx="5486400" cy="3600450"/>
+          </a:xfrm>
+          <a:prstGeom prst="rect">
+            <a:avLst/>
+          </a:prstGeom>
+        </p:spPr>
+        <p:txBody>
+          <a:bodyPr vert="horz" lIns="91440" tIns="45720" rIns="91440" bIns="45720" rtlCol="0"/>
+          <a:lstStyle/>
+          <a:p>
+            <a:pPr lvl="0"/>
+            <a:r>
+              <a:rPr lang="en-US"/>
+              <a:t>Click to edit Master text styles</a:t>
+            </a:r>
+          </a:p>
+          <a:p>
+            <a:pPr lvl="1"/>
+            <a:r>
+              <a:rPr lang="en-US"/>
+              <a:t>Second level</a:t>
+            </a:r>
+          </a:p>
+          <a:p>
+            <a:pPr lvl="2"/>
+            <a:r>
+              <a:rPr lang="en-US"/>
+              <a:t>Third level</a:t>
+            </a:r>
+          </a:p>
+          <a:p>
+            <a:pPr lvl="3"/>
+            <a:r>
+              <a:rPr lang="en-US"/>
+              <a:t>Fourth level</a:t>
+            </a:r>
+          </a:p>
+          <a:p>
+            <a:pPr lvl="4"/>
+            <a:r>
+              <a:rPr lang="en-US"/>
+              <a:t>Fifth level</a:t>
+            </a:r>
+          </a:p>
+        </p:txBody>
+      </p:sp>
+      <p:sp>
+        <p:nvSpPr>
+          <p:cNvPr id="6" name="Footer Placeholder 5"/>
+          <p:cNvSpPr>
+            <a:spLocks noGrp="1"/>
+          </p:cNvSpPr>
+          <p:nvPr>
+            <p:ph type="ftr" sz="quarter" idx="4"/>
+          </p:nvPr>
+        </p:nvSpPr>
+        <p:spPr>
+          <a:xfrm>
+            <a:off x="0" y="8685213"/>
+            <a:ext cx="2971800" cy="458787"/>
+          </a:xfrm>
+          <a:prstGeom prst="rect">
+            <a:avLst/>
+          </a:prstGeom>
+        </p:spPr>
+        <p:txBody>
+          <a:bodyPr vert="horz" lIns="91440" tIns="45720" rIns="91440" bIns="45720" rtlCol="0" anchor="b"/>
+          <a:lstStyle>
+            <a:lvl1pPr algn="l">
+              <a:defRPr sz="1200"/>
+            </a:lvl1pPr>
+          </a:lstStyle>
+          <a:p>
+            <a:endParaRPr lang="en-US"/>
+          </a:p>
+        </p:txBody>
+      </p:sp>
+      <p:sp>
+        <p:nvSpPr>
+          <p:cNvPr id="7" name="Slide Number Placeholder 6"/>
+          <p:cNvSpPr>
+            <a:spLocks noGrp="1"/>
+          </p:cNvSpPr>
+          <p:nvPr>
+            <p:ph type="sldNum" sz="quarter" idx="5"/>
+          </p:nvPr>
+        </p:nvSpPr>
+        <p:spPr>
+          <a:xfrm>
+            <a:off x="3884613" y="8685213"/>
+            <a:ext cx="2971800" cy="458787"/>
+          </a:xfrm>
+          <a:prstGeom prst="rect">
+            <a:avLst/>
+          </a:prstGeom>
+        </p:spPr>
+        <p:txBody>
+          <a:bodyPr vert="horz" lIns="91440" tIns="45720" rIns="91440" bIns="45720" rtlCol="0" anchor="b"/>
+          <a:lstStyle>
+            <a:lvl1pPr algn="r">
+              <a:defRPr sz="1200"/>
+            </a:lvl1pPr>
+          </a:lstStyle>
+          <a:p>
+            <a:fld id="{23A4113C-5E28-1640-8EDB-2A6F282456C0}" type="slidenum">
+              <a:rPr lang="en-US" smtClean="0"/>
+              <a:t>‹#›</a:t>
+            </a:fld>
+            <a:endParaRPr lang="en-US"/>
+          </a:p>
+        </p:txBody>
+      </p:sp>
+    </p:spTree>
+    <p:extLst>
+      <p:ext uri="{BB962C8B-B14F-4D97-AF65-F5344CB8AC3E}">
+        <p14:creationId xmlns:p14="http://schemas.microsoft.com/office/powerpoint/2010/main" val="4138932067"/>
+      </p:ext>
+    </p:extLst>
+  </p:cSld>
+  <p:clrMap bg1="lt1" tx1="dk1" bg2="lt2" tx2="dk2" accent1="accent1" accent2="accent2" accent3="accent3" accent4="accent4" accent5="accent5" accent6="accent6" hlink="hlink" folHlink="folHlink"/>
+  <p:notesStyle>
+    <a:lvl1pPr marL="0" algn="l" defTabSz="914400" rtl="0" eaLnBrk="1" latinLnBrk="0" hangingPunct="1">
+      <a:defRPr sz="1200" kern="1200">
+        <a:solidFill>
+          <a:schemeClr val="tx1"/>
+        </a:solidFill>
+        <a:latin typeface="+mn-lt"/>
+        <a:ea typeface="+mn-ea"/>
+        <a:cs typeface="+mn-cs"/>
+      </a:defRPr>
+    </a:lvl1pPr>
+    <a:lvl2pPr marL="457200" algn="l" defTabSz="914400" rtl="0" eaLnBrk="1" latinLnBrk="0" hangingPunct="1">
+      <a:defRPr sz="1200" kern="1200">
+        <a:solidFill>
+          <a:schemeClr val="tx1"/>
+        </a:solidFill>
+        <a:latin typeface="+mn-lt"/>
+        <a:ea typeface="+mn-ea"/>
+        <a:cs typeface="+mn-cs"/>
+      </a:defRPr>
+    </a:lvl2pPr>
+    <a:lvl3pPr marL="914400" algn="l" defTabSz="914400" rtl="0" eaLnBrk="1" latinLnBrk="0" hangingPunct="1">
+      <a:defRPr sz="1200" kern="1200">
+        <a:solidFill>
+          <a:schemeClr val="tx1"/>
+        </a:solidFill>
+        <a:latin typeface="+mn-lt"/>
+        <a:ea typeface="+mn-ea"/>
+        <a:cs typeface="+mn-cs"/>
+      </a:defRPr>
+    </a:lvl3pPr>
+    <a:lvl4pPr marL="1371600" algn="l" defTabSz="914400" rtl="0" eaLnBrk="1" latinLnBrk="0" hangingPunct="1">
+      <a:defRPr sz="1200" kern="1200">
+        <a:solidFill>
+          <a:schemeClr val="tx1"/>
+        </a:solidFill>
+        <a:latin typeface="+mn-lt"/>
+        <a:ea typeface="+mn-ea"/>
+        <a:cs typeface="+mn-cs"/>
+      </a:defRPr>
+    </a:lvl4pPr>
+    <a:lvl5pPr marL="1828800" algn="l" defTabSz="914400" rtl="0" eaLnBrk="1" latinLnBrk="0" hangingPunct="1">
+      <a:defRPr sz="1200" kern="1200">
+        <a:solidFill>
+          <a:schemeClr val="tx1"/>
+        </a:solidFill>
+        <a:latin typeface="+mn-lt"/>
+        <a:ea typeface="+mn-ea"/>
+        <a:cs typeface="+mn-cs"/>
+      </a:defRPr>
+    </a:lvl5pPr>
+    <a:lvl6pPr marL="2286000" algn="l" defTabSz="914400" rtl="0" eaLnBrk="1" latinLnBrk="0" hangingPunct="1">
+      <a:defRPr sz="1200" kern="1200">
+        <a:solidFill>
+          <a:schemeClr val="tx1"/>
+        </a:solidFill>
+        <a:latin typeface="+mn-lt"/>
+        <a:ea typeface="+mn-ea"/>
+        <a:cs typeface="+mn-cs"/>
+      </a:defRPr>
+    </a:lvl6pPr>
+    <a:lvl7pPr marL="2743200" algn="l" defTabSz="914400" rtl="0" eaLnBrk="1" latinLnBrk="0" hangingPunct="1">
+      <a:defRPr sz="1200" kern="1200">
+        <a:solidFill>
+          <a:schemeClr val="tx1"/>
+        </a:solidFill>
+        <a:latin typeface="+mn-lt"/>
+        <a:ea typeface="+mn-ea"/>
+        <a:cs typeface="+mn-cs"/>
+      </a:defRPr>
+    </a:lvl7pPr>
+    <a:lvl8pPr marL="3200400" algn="l" defTabSz="914400" rtl="0" eaLnBrk="1" latinLnBrk="0" hangingPunct="1">
+      <a:defRPr sz="1200" kern="1200">
+        <a:solidFill>
+          <a:schemeClr val="tx1"/>
+        </a:solidFill>
+        <a:latin typeface="+mn-lt"/>
+        <a:ea typeface="+mn-ea"/>
+        <a:cs typeface="+mn-cs"/>
+      </a:defRPr>
+    </a:lvl8pPr>
+    <a:lvl9pPr marL="3657600" algn="l" defTabSz="914400" rtl="0" eaLnBrk="1" latinLnBrk="0" hangingPunct="1">
+      <a:defRPr sz="1200" kern="1200">
+        <a:solidFill>
+          <a:schemeClr val="tx1"/>
+        </a:solidFill>
+        <a:latin typeface="+mn-lt"/>
+        <a:ea typeface="+mn-ea"/>
+        <a:cs typeface="+mn-cs"/>
+      </a:defRPr>
+    </a:lvl9pPr>
+  </p:notesStyle>
+</p:notesMaster>
+</file>
+
+<file path=ppt/notesSlides/notesSlide1.xml><?xml version="1.0" encoding="utf-8"?>
+<p:notes xmlns:a="http://schemas.openxmlformats.org/drawingml/2006/main" xmlns:r="http://schemas.openxmlformats.org/officeDocument/2006/relationships" xmlns:p="http://schemas.openxmlformats.org/presentationml/2006/main">
+  <p:cSld>
+    <p:spTree>
+      <p:nvGrpSpPr>
+        <p:cNvPr id="1" name=""/>
+        <p:cNvGrpSpPr/>
+        <p:nvPr/>
+      </p:nvGrpSpPr>
+      <p:grpSpPr>
+        <a:xfrm>
+          <a:off x="0" y="0"/>
+          <a:ext cx="0" cy="0"/>
+          <a:chOff x="0" y="0"/>
+          <a:chExt cx="0" cy="0"/>
+        </a:xfrm>
+      </p:grpSpPr>
+      <p:sp>
+        <p:nvSpPr>
+          <p:cNvPr id="2" name="Slide Image Placeholder 1"/>
+          <p:cNvSpPr>
+            <a:spLocks noGrp="1" noRot="1" noChangeAspect="1"/>
+          </p:cNvSpPr>
+          <p:nvPr>
+            <p:ph type="sldImg"/>
+          </p:nvPr>
+        </p:nvSpPr>
+        <p:spPr/>
+      </p:sp>
+      <p:sp>
+        <p:nvSpPr>
+          <p:cNvPr id="3" name="Notes Placeholder 2"/>
+          <p:cNvSpPr>
+            <a:spLocks noGrp="1"/>
+          </p:cNvSpPr>
+          <p:nvPr>
+            <p:ph type="body" idx="1"/>
+          </p:nvPr>
+        </p:nvSpPr>
+        <p:spPr/>
+        <p:txBody>
+          <a:bodyPr/>
+          <a:lstStyle/>
+          <a:p>
+            <a:endParaRPr lang="en-US"/>
+          </a:p>
+        </p:txBody>
+      </p:sp>
+      <p:sp>
+        <p:nvSpPr>
+          <p:cNvPr id="4" name="Slide Number Placeholder 3"/>
+          <p:cNvSpPr>
+            <a:spLocks noGrp="1"/>
+          </p:cNvSpPr>
+          <p:nvPr>
+            <p:ph type="sldNum" sz="quarter" idx="5"/>
+          </p:nvPr>
+        </p:nvSpPr>
+        <p:spPr/>
+        <p:txBody>
+          <a:bodyPr/>
+          <a:lstStyle/>
+          <a:p>
+            <a:fld id="{23A4113C-5E28-1640-8EDB-2A6F282456C0}" type="slidenum">
+              <a:rPr lang="en-US" smtClean="0"/>
+              <a:t>2</a:t>
+            </a:fld>
+            <a:endParaRPr lang="en-US"/>
+          </a:p>
+        </p:txBody>
+      </p:sp>
+    </p:spTree>
+    <p:extLst>
+      <p:ext uri="{BB962C8B-B14F-4D97-AF65-F5344CB8AC3E}">
+        <p14:creationId xmlns:p14="http://schemas.microsoft.com/office/powerpoint/2010/main" val="1793553040"/>
+      </p:ext>
+    </p:extLst>
+  </p:cSld>
+  <p:clrMapOvr>
+    <a:masterClrMapping/>
+  </p:clrMapOvr>
+</p:notes>
 </file>
 
 <file path=ppt/slideLayouts/slideLayout1.xml><?xml version="1.0" encoding="utf-8"?>
@@ -145,10 +598,9 @@
           <a:lstStyle/>
           <a:p>
             <a:r>
-              <a:rPr lang="en-US" smtClean="0"/>
+              <a:rPr lang="en-US"/>
               <a:t>Click to edit Master title style</a:t>
             </a:r>
-            <a:endParaRPr lang="en-US"/>
           </a:p>
         </p:txBody>
       </p:sp>
@@ -264,10 +716,9 @@
           </a:lstStyle>
           <a:p>
             <a:r>
-              <a:rPr lang="en-US" smtClean="0"/>
+              <a:rPr lang="en-US"/>
               <a:t>Click to edit Master subtitle style</a:t>
             </a:r>
-            <a:endParaRPr lang="en-US"/>
           </a:p>
         </p:txBody>
       </p:sp>
@@ -288,7 +739,7 @@
           <a:p>
             <a:fld id="{5BCAD085-E8A6-8845-BD4E-CB4CCA059FC4}" type="datetimeFigureOut">
               <a:rPr lang="en-US" smtClean="0"/>
-              <a:t>1/27/13</a:t>
+              <a:t>5/3/26</a:t>
             </a:fld>
             <a:endParaRPr lang="en-US"/>
           </a:p>
@@ -382,10 +833,9 @@
           <a:lstStyle/>
           <a:p>
             <a:r>
-              <a:rPr lang="en-US" smtClean="0"/>
+              <a:rPr lang="en-US"/>
               <a:t>Click to edit Master title style</a:t>
             </a:r>
-            <a:endParaRPr lang="en-US"/>
           </a:p>
         </p:txBody>
       </p:sp>
@@ -406,38 +856,37 @@
           <a:p>
             <a:pPr lvl="0"/>
             <a:r>
-              <a:rPr lang="en-US" smtClean="0"/>
+              <a:rPr lang="en-US"/>
               <a:t>Click to edit Master text styles</a:t>
             </a:r>
           </a:p>
           <a:p>
             <a:pPr lvl="1"/>
             <a:r>
-              <a:rPr lang="en-US" smtClean="0"/>
+              <a:rPr lang="en-US"/>
               <a:t>Second level</a:t>
             </a:r>
           </a:p>
           <a:p>
             <a:pPr lvl="2"/>
             <a:r>
-              <a:rPr lang="en-US" smtClean="0"/>
+              <a:rPr lang="en-US"/>
               <a:t>Third level</a:t>
             </a:r>
           </a:p>
           <a:p>
             <a:pPr lvl="3"/>
             <a:r>
-              <a:rPr lang="en-US" smtClean="0"/>
+              <a:rPr lang="en-US"/>
               <a:t>Fourth level</a:t>
             </a:r>
           </a:p>
           <a:p>
             <a:pPr lvl="4"/>
             <a:r>
-              <a:rPr lang="en-US" smtClean="0"/>
+              <a:rPr lang="en-US"/>
               <a:t>Fifth level</a:t>
             </a:r>
-            <a:endParaRPr lang="en-US"/>
           </a:p>
         </p:txBody>
       </p:sp>
@@ -458,7 +907,7 @@
           <a:p>
             <a:fld id="{5BCAD085-E8A6-8845-BD4E-CB4CCA059FC4}" type="datetimeFigureOut">
               <a:rPr lang="en-US" smtClean="0"/>
-              <a:t>1/27/13</a:t>
+              <a:t>5/3/26</a:t>
             </a:fld>
             <a:endParaRPr lang="en-US"/>
           </a:p>
@@ -557,10 +1006,9 @@
           <a:lstStyle/>
           <a:p>
             <a:r>
-              <a:rPr lang="en-US" smtClean="0"/>
+              <a:rPr lang="en-US"/>
               <a:t>Click to edit Master title style</a:t>
             </a:r>
-            <a:endParaRPr lang="en-US"/>
           </a:p>
         </p:txBody>
       </p:sp>
@@ -586,38 +1034,37 @@
           <a:p>
             <a:pPr lvl="0"/>
             <a:r>
-              <a:rPr lang="en-US" smtClean="0"/>
+              <a:rPr lang="en-US"/>
               <a:t>Click to edit Master text styles</a:t>
             </a:r>
           </a:p>
           <a:p>
             <a:pPr lvl="1"/>
             <a:r>
-              <a:rPr lang="en-US" smtClean="0"/>
+              <a:rPr lang="en-US"/>
               <a:t>Second level</a:t>
             </a:r>
           </a:p>
           <a:p>
             <a:pPr lvl="2"/>
             <a:r>
-              <a:rPr lang="en-US" smtClean="0"/>
+              <a:rPr lang="en-US"/>
               <a:t>Third level</a:t>
             </a:r>
           </a:p>
           <a:p>
             <a:pPr lvl="3"/>
             <a:r>
-              <a:rPr lang="en-US" smtClean="0"/>
+              <a:rPr lang="en-US"/>
               <a:t>Fourth level</a:t>
             </a:r>
           </a:p>
           <a:p>
             <a:pPr lvl="4"/>
             <a:r>
-              <a:rPr lang="en-US" smtClean="0"/>
+              <a:rPr lang="en-US"/>
               <a:t>Fifth level</a:t>
             </a:r>
-            <a:endParaRPr lang="en-US"/>
           </a:p>
         </p:txBody>
       </p:sp>
@@ -638,7 +1085,7 @@
           <a:p>
             <a:fld id="{5BCAD085-E8A6-8845-BD4E-CB4CCA059FC4}" type="datetimeFigureOut">
               <a:rPr lang="en-US" smtClean="0"/>
-              <a:t>1/27/13</a:t>
+              <a:t>5/3/26</a:t>
             </a:fld>
             <a:endParaRPr lang="en-US"/>
           </a:p>
@@ -732,10 +1179,9 @@
           <a:lstStyle/>
           <a:p>
             <a:r>
-              <a:rPr lang="en-US" smtClean="0"/>
+              <a:rPr lang="en-US"/>
               <a:t>Click to edit Master title style</a:t>
             </a:r>
-            <a:endParaRPr lang="en-US"/>
           </a:p>
         </p:txBody>
       </p:sp>
@@ -756,38 +1202,37 @@
           <a:p>
             <a:pPr lvl="0"/>
             <a:r>
-              <a:rPr lang="en-US" smtClean="0"/>
+              <a:rPr lang="en-US"/>
               <a:t>Click to edit Master text styles</a:t>
             </a:r>
           </a:p>
           <a:p>
             <a:pPr lvl="1"/>
             <a:r>
-              <a:rPr lang="en-US" smtClean="0"/>
+              <a:rPr lang="en-US"/>
               <a:t>Second level</a:t>
             </a:r>
           </a:p>
           <a:p>
             <a:pPr lvl="2"/>
             <a:r>
-              <a:rPr lang="en-US" smtClean="0"/>
+              <a:rPr lang="en-US"/>
               <a:t>Third level</a:t>
             </a:r>
           </a:p>
           <a:p>
             <a:pPr lvl="3"/>
             <a:r>
-              <a:rPr lang="en-US" smtClean="0"/>
+              <a:rPr lang="en-US"/>
               <a:t>Fourth level</a:t>
             </a:r>
           </a:p>
           <a:p>
             <a:pPr lvl="4"/>
             <a:r>
-              <a:rPr lang="en-US" smtClean="0"/>
+              <a:rPr lang="en-US"/>
               <a:t>Fifth level</a:t>
             </a:r>
-            <a:endParaRPr lang="en-US"/>
           </a:p>
         </p:txBody>
       </p:sp>
@@ -808,7 +1253,7 @@
           <a:p>
             <a:fld id="{5BCAD085-E8A6-8845-BD4E-CB4CCA059FC4}" type="datetimeFigureOut">
               <a:rPr lang="en-US" smtClean="0"/>
-              <a:t>1/27/13</a:t>
+              <a:t>5/3/26</a:t>
             </a:fld>
             <a:endParaRPr lang="en-US"/>
           </a:p>
@@ -911,10 +1356,9 @@
           </a:lstStyle>
           <a:p>
             <a:r>
-              <a:rPr lang="en-US" smtClean="0"/>
+              <a:rPr lang="en-US"/>
               <a:t>Click to edit Master title style</a:t>
             </a:r>
-            <a:endParaRPr lang="en-US"/>
           </a:p>
         </p:txBody>
       </p:sp>
@@ -1031,7 +1475,7 @@
           <a:p>
             <a:pPr lvl="0"/>
             <a:r>
-              <a:rPr lang="en-US" smtClean="0"/>
+              <a:rPr lang="en-US"/>
               <a:t>Click to edit Master text styles</a:t>
             </a:r>
           </a:p>
@@ -1054,7 +1498,7 @@
           <a:p>
             <a:fld id="{5BCAD085-E8A6-8845-BD4E-CB4CCA059FC4}" type="datetimeFigureOut">
               <a:rPr lang="en-US" smtClean="0"/>
-              <a:t>1/27/13</a:t>
+              <a:t>5/3/26</a:t>
             </a:fld>
             <a:endParaRPr lang="en-US"/>
           </a:p>
@@ -1148,10 +1592,9 @@
           <a:lstStyle/>
           <a:p>
             <a:r>
-              <a:rPr lang="en-US" smtClean="0"/>
+              <a:rPr lang="en-US"/>
               <a:t>Click to edit Master title style</a:t>
             </a:r>
-            <a:endParaRPr lang="en-US"/>
           </a:p>
         </p:txBody>
       </p:sp>
@@ -1205,38 +1648,37 @@
           <a:p>
             <a:pPr lvl="0"/>
             <a:r>
-              <a:rPr lang="en-US" smtClean="0"/>
+              <a:rPr lang="en-US"/>
               <a:t>Click to edit Master text styles</a:t>
             </a:r>
           </a:p>
           <a:p>
             <a:pPr lvl="1"/>
             <a:r>
-              <a:rPr lang="en-US" smtClean="0"/>
+              <a:rPr lang="en-US"/>
               <a:t>Second level</a:t>
             </a:r>
           </a:p>
           <a:p>
             <a:pPr lvl="2"/>
             <a:r>
-              <a:rPr lang="en-US" smtClean="0"/>
+              <a:rPr lang="en-US"/>
               <a:t>Third level</a:t>
             </a:r>
           </a:p>
           <a:p>
             <a:pPr lvl="3"/>
             <a:r>
-              <a:rPr lang="en-US" smtClean="0"/>
+              <a:rPr lang="en-US"/>
               <a:t>Fourth level</a:t>
             </a:r>
           </a:p>
           <a:p>
             <a:pPr lvl="4"/>
             <a:r>
-              <a:rPr lang="en-US" smtClean="0"/>
+              <a:rPr lang="en-US"/>
               <a:t>Fifth level</a:t>
             </a:r>
-            <a:endParaRPr lang="en-US"/>
           </a:p>
         </p:txBody>
       </p:sp>
@@ -1290,38 +1732,37 @@
           <a:p>
             <a:pPr lvl="0"/>
             <a:r>
-              <a:rPr lang="en-US" smtClean="0"/>
+              <a:rPr lang="en-US"/>
               <a:t>Click to edit Master text styles</a:t>
             </a:r>
           </a:p>
           <a:p>
             <a:pPr lvl="1"/>
             <a:r>
-              <a:rPr lang="en-US" smtClean="0"/>
+              <a:rPr lang="en-US"/>
               <a:t>Second level</a:t>
             </a:r>
           </a:p>
           <a:p>
             <a:pPr lvl="2"/>
             <a:r>
-              <a:rPr lang="en-US" smtClean="0"/>
+              <a:rPr lang="en-US"/>
               <a:t>Third level</a:t>
             </a:r>
           </a:p>
           <a:p>
             <a:pPr lvl="3"/>
             <a:r>
-              <a:rPr lang="en-US" smtClean="0"/>
+              <a:rPr lang="en-US"/>
               <a:t>Fourth level</a:t>
             </a:r>
           </a:p>
           <a:p>
             <a:pPr lvl="4"/>
             <a:r>
-              <a:rPr lang="en-US" smtClean="0"/>
+              <a:rPr lang="en-US"/>
               <a:t>Fifth level</a:t>
             </a:r>
-            <a:endParaRPr lang="en-US"/>
           </a:p>
         </p:txBody>
       </p:sp>
@@ -1342,7 +1783,7 @@
           <a:p>
             <a:fld id="{5BCAD085-E8A6-8845-BD4E-CB4CCA059FC4}" type="datetimeFigureOut">
               <a:rPr lang="en-US" smtClean="0"/>
-              <a:t>1/27/13</a:t>
+              <a:t>5/3/26</a:t>
             </a:fld>
             <a:endParaRPr lang="en-US"/>
           </a:p>
@@ -1440,10 +1881,9 @@
           </a:lstStyle>
           <a:p>
             <a:r>
-              <a:rPr lang="en-US" smtClean="0"/>
+              <a:rPr lang="en-US"/>
               <a:t>Click to edit Master title style</a:t>
             </a:r>
-            <a:endParaRPr lang="en-US"/>
           </a:p>
         </p:txBody>
       </p:sp>
@@ -1506,7 +1946,7 @@
           <a:p>
             <a:pPr lvl="0"/>
             <a:r>
-              <a:rPr lang="en-US" smtClean="0"/>
+              <a:rPr lang="en-US"/>
               <a:t>Click to edit Master text styles</a:t>
             </a:r>
           </a:p>
@@ -1562,38 +2002,37 @@
           <a:p>
             <a:pPr lvl="0"/>
             <a:r>
-              <a:rPr lang="en-US" smtClean="0"/>
+              <a:rPr lang="en-US"/>
               <a:t>Click to edit Master text styles</a:t>
             </a:r>
           </a:p>
           <a:p>
             <a:pPr lvl="1"/>
             <a:r>
-              <a:rPr lang="en-US" smtClean="0"/>
+              <a:rPr lang="en-US"/>
               <a:t>Second level</a:t>
             </a:r>
           </a:p>
           <a:p>
             <a:pPr lvl="2"/>
             <a:r>
-              <a:rPr lang="en-US" smtClean="0"/>
+              <a:rPr lang="en-US"/>
               <a:t>Third level</a:t>
             </a:r>
           </a:p>
           <a:p>
             <a:pPr lvl="3"/>
             <a:r>
-              <a:rPr lang="en-US" smtClean="0"/>
+              <a:rPr lang="en-US"/>
               <a:t>Fourth level</a:t>
             </a:r>
           </a:p>
           <a:p>
             <a:pPr lvl="4"/>
             <a:r>
-              <a:rPr lang="en-US" smtClean="0"/>
+              <a:rPr lang="en-US"/>
               <a:t>Fifth level</a:t>
             </a:r>
-            <a:endParaRPr lang="en-US"/>
           </a:p>
         </p:txBody>
       </p:sp>
@@ -1656,7 +2095,7 @@
           <a:p>
             <a:pPr lvl="0"/>
             <a:r>
-              <a:rPr lang="en-US" smtClean="0"/>
+              <a:rPr lang="en-US"/>
               <a:t>Click to edit Master text styles</a:t>
             </a:r>
           </a:p>
@@ -1712,38 +2151,37 @@
           <a:p>
             <a:pPr lvl="0"/>
             <a:r>
-              <a:rPr lang="en-US" smtClean="0"/>
+              <a:rPr lang="en-US"/>
               <a:t>Click to edit Master text styles</a:t>
             </a:r>
           </a:p>
           <a:p>
             <a:pPr lvl="1"/>
             <a:r>
-              <a:rPr lang="en-US" smtClean="0"/>
+              <a:rPr lang="en-US"/>
               <a:t>Second level</a:t>
             </a:r>
           </a:p>
           <a:p>
             <a:pPr lvl="2"/>
             <a:r>
-              <a:rPr lang="en-US" smtClean="0"/>
+              <a:rPr lang="en-US"/>
               <a:t>Third level</a:t>
             </a:r>
           </a:p>
           <a:p>
             <a:pPr lvl="3"/>
             <a:r>
-              <a:rPr lang="en-US" smtClean="0"/>
+              <a:rPr lang="en-US"/>
               <a:t>Fourth level</a:t>
             </a:r>
           </a:p>
           <a:p>
             <a:pPr lvl="4"/>
             <a:r>
-              <a:rPr lang="en-US" smtClean="0"/>
+              <a:rPr lang="en-US"/>
               <a:t>Fifth level</a:t>
             </a:r>
-            <a:endParaRPr lang="en-US"/>
           </a:p>
         </p:txBody>
       </p:sp>
@@ -1764,7 +2202,7 @@
           <a:p>
             <a:fld id="{5BCAD085-E8A6-8845-BD4E-CB4CCA059FC4}" type="datetimeFigureOut">
               <a:rPr lang="en-US" smtClean="0"/>
-              <a:t>1/27/13</a:t>
+              <a:t>5/3/26</a:t>
             </a:fld>
             <a:endParaRPr lang="en-US"/>
           </a:p>
@@ -1858,10 +2296,9 @@
           <a:lstStyle/>
           <a:p>
             <a:r>
-              <a:rPr lang="en-US" smtClean="0"/>
+              <a:rPr lang="en-US"/>
               <a:t>Click to edit Master title style</a:t>
             </a:r>
-            <a:endParaRPr lang="en-US"/>
           </a:p>
         </p:txBody>
       </p:sp>
@@ -1882,7 +2319,7 @@
           <a:p>
             <a:fld id="{5BCAD085-E8A6-8845-BD4E-CB4CCA059FC4}" type="datetimeFigureOut">
               <a:rPr lang="en-US" smtClean="0"/>
-              <a:t>1/27/13</a:t>
+              <a:t>5/3/26</a:t>
             </a:fld>
             <a:endParaRPr lang="en-US"/>
           </a:p>
@@ -1977,7 +2414,7 @@
           <a:p>
             <a:fld id="{5BCAD085-E8A6-8845-BD4E-CB4CCA059FC4}" type="datetimeFigureOut">
               <a:rPr lang="en-US" smtClean="0"/>
-              <a:t>1/27/13</a:t>
+              <a:t>5/3/26</a:t>
             </a:fld>
             <a:endParaRPr lang="en-US"/>
           </a:p>
@@ -2080,10 +2517,9 @@
           </a:lstStyle>
           <a:p>
             <a:r>
-              <a:rPr lang="en-US" smtClean="0"/>
+              <a:rPr lang="en-US"/>
               <a:t>Click to edit Master title style</a:t>
             </a:r>
-            <a:endParaRPr lang="en-US"/>
           </a:p>
         </p:txBody>
       </p:sp>
@@ -2137,38 +2573,37 @@
           <a:p>
             <a:pPr lvl="0"/>
             <a:r>
-              <a:rPr lang="en-US" smtClean="0"/>
+              <a:rPr lang="en-US"/>
               <a:t>Click to edit Master text styles</a:t>
             </a:r>
           </a:p>
           <a:p>
             <a:pPr lvl="1"/>
             <a:r>
-              <a:rPr lang="en-US" smtClean="0"/>
+              <a:rPr lang="en-US"/>
               <a:t>Second level</a:t>
             </a:r>
           </a:p>
           <a:p>
             <a:pPr lvl="2"/>
             <a:r>
-              <a:rPr lang="en-US" smtClean="0"/>
+              <a:rPr lang="en-US"/>
               <a:t>Third level</a:t>
             </a:r>
           </a:p>
           <a:p>
             <a:pPr lvl="3"/>
             <a:r>
-              <a:rPr lang="en-US" smtClean="0"/>
+              <a:rPr lang="en-US"/>
               <a:t>Fourth level</a:t>
             </a:r>
           </a:p>
           <a:p>
             <a:pPr lvl="4"/>
             <a:r>
-              <a:rPr lang="en-US" smtClean="0"/>
+              <a:rPr lang="en-US"/>
               <a:t>Fifth level</a:t>
             </a:r>
-            <a:endParaRPr lang="en-US"/>
           </a:p>
         </p:txBody>
       </p:sp>
@@ -2231,7 +2666,7 @@
           <a:p>
             <a:pPr lvl="0"/>
             <a:r>
-              <a:rPr lang="en-US" smtClean="0"/>
+              <a:rPr lang="en-US"/>
               <a:t>Click to edit Master text styles</a:t>
             </a:r>
           </a:p>
@@ -2254,7 +2689,7 @@
           <a:p>
             <a:fld id="{5BCAD085-E8A6-8845-BD4E-CB4CCA059FC4}" type="datetimeFigureOut">
               <a:rPr lang="en-US" smtClean="0"/>
-              <a:t>1/27/13</a:t>
+              <a:t>5/3/26</a:t>
             </a:fld>
             <a:endParaRPr lang="en-US"/>
           </a:p>
@@ -2357,10 +2792,9 @@
           </a:lstStyle>
           <a:p>
             <a:r>
-              <a:rPr lang="en-US" smtClean="0"/>
+              <a:rPr lang="en-US"/>
               <a:t>Click to edit Master title style</a:t>
             </a:r>
-            <a:endParaRPr lang="en-US"/>
           </a:p>
         </p:txBody>
       </p:sp>
@@ -2484,7 +2918,7 @@
           <a:p>
             <a:pPr lvl="0"/>
             <a:r>
-              <a:rPr lang="en-US" smtClean="0"/>
+              <a:rPr lang="en-US"/>
               <a:t>Click to edit Master text styles</a:t>
             </a:r>
           </a:p>
@@ -2507,7 +2941,7 @@
           <a:p>
             <a:fld id="{5BCAD085-E8A6-8845-BD4E-CB4CCA059FC4}" type="datetimeFigureOut">
               <a:rPr lang="en-US" smtClean="0"/>
-              <a:t>1/27/13</a:t>
+              <a:t>5/3/26</a:t>
             </a:fld>
             <a:endParaRPr lang="en-US"/>
           </a:p>
@@ -2616,10 +3050,9 @@
           <a:lstStyle/>
           <a:p>
             <a:r>
-              <a:rPr lang="en-US" smtClean="0"/>
+              <a:rPr lang="en-US"/>
               <a:t>Click to edit Master title style</a:t>
             </a:r>
-            <a:endParaRPr lang="en-US"/>
           </a:p>
         </p:txBody>
       </p:sp>
@@ -2650,38 +3083,37 @@
           <a:p>
             <a:pPr lvl="0"/>
             <a:r>
-              <a:rPr lang="en-US" smtClean="0"/>
+              <a:rPr lang="en-US"/>
               <a:t>Click to edit Master text styles</a:t>
             </a:r>
           </a:p>
           <a:p>
             <a:pPr lvl="1"/>
             <a:r>
-              <a:rPr lang="en-US" smtClean="0"/>
+              <a:rPr lang="en-US"/>
               <a:t>Second level</a:t>
             </a:r>
           </a:p>
           <a:p>
             <a:pPr lvl="2"/>
             <a:r>
-              <a:rPr lang="en-US" smtClean="0"/>
+              <a:rPr lang="en-US"/>
               <a:t>Third level</a:t>
             </a:r>
           </a:p>
           <a:p>
             <a:pPr lvl="3"/>
             <a:r>
-              <a:rPr lang="en-US" smtClean="0"/>
+              <a:rPr lang="en-US"/>
               <a:t>Fourth level</a:t>
             </a:r>
           </a:p>
           <a:p>
             <a:pPr lvl="4"/>
             <a:r>
-              <a:rPr lang="en-US" smtClean="0"/>
+              <a:rPr lang="en-US"/>
               <a:t>Fifth level</a:t>
             </a:r>
-            <a:endParaRPr lang="en-US"/>
           </a:p>
         </p:txBody>
       </p:sp>
@@ -2720,7 +3152,7 @@
           <a:p>
             <a:fld id="{5BCAD085-E8A6-8845-BD4E-CB4CCA059FC4}" type="datetimeFigureOut">
               <a:rPr lang="en-US" smtClean="0"/>
-              <a:t>1/27/13</a:t>
+              <a:t>5/3/26</a:t>
             </a:fld>
             <a:endParaRPr lang="en-US"/>
           </a:p>
@@ -3079,7 +3511,7 @@
 </file>
 
 <file path=ppt/slides/slide1.xml><?xml version="1.0" encoding="utf-8"?>
-<p:sld xmlns:a="http://schemas.openxmlformats.org/drawingml/2006/main" xmlns:p="http://schemas.openxmlformats.org/presentationml/2006/main" xmlns:r="http://schemas.openxmlformats.org/officeDocument/2006/relationships">
+<p:sld xmlns:a="http://schemas.openxmlformats.org/drawingml/2006/main" xmlns:r="http://schemas.openxmlformats.org/officeDocument/2006/relationships" xmlns:p="http://schemas.openxmlformats.org/presentationml/2006/main">
   <p:cSld>
     <p:bg>
       <p:bgPr>
@@ -3095,7 +3527,14 @@
         <p:cNvGrpSpPr/>
         <p:nvPr/>
       </p:nvGrpSpPr>
-      <p:grpSpPr/>
+      <p:grpSpPr>
+        <a:xfrm>
+          <a:off x="0" y="0"/>
+          <a:ext cx="0" cy="0"/>
+          <a:chOff x="0" y="0"/>
+          <a:chExt cx="0" cy="0"/>
+        </a:xfrm>
+      </p:grpSpPr>
       <p:sp>
         <p:nvSpPr>
           <p:cNvPr id="2" name="TextBox 1"/>
@@ -3113,14 +3552,14 @@
           <a:noFill/>
         </p:spPr>
         <p:txBody>
-          <a:bodyPr wrap="none" lIns="54864" rIns="54864" tIns="36576" bIns="36576">
+          <a:bodyPr wrap="none" lIns="54864" tIns="36576" rIns="54864" bIns="36576">
             <a:spAutoFit/>
           </a:bodyPr>
           <a:lstStyle/>
           <a:p>
             <a:pPr algn="l"/>
             <a:r>
-              <a:rPr sz="1800" b="1">
+              <a:rPr sz="1800" b="1" dirty="0">
                 <a:solidFill>
                   <a:srgbClr val="172033"/>
                 </a:solidFill>
@@ -3148,14 +3587,14 @@
           <a:noFill/>
         </p:spPr>
         <p:txBody>
-          <a:bodyPr wrap="none" lIns="54864" rIns="54864" tIns="36576" bIns="36576">
+          <a:bodyPr wrap="none" lIns="54864" tIns="36576" rIns="54864" bIns="36576">
             <a:spAutoFit/>
           </a:bodyPr>
           <a:lstStyle/>
           <a:p>
             <a:pPr algn="l"/>
             <a:r>
-              <a:rPr sz="900" b="0">
+              <a:rPr sz="900" b="0" dirty="0">
                 <a:solidFill>
                   <a:srgbClr val="64748B"/>
                 </a:solidFill>
@@ -3204,12 +3643,12 @@
           </a:fontRef>
         </p:style>
         <p:txBody>
-          <a:bodyPr rtlCol="0" anchor="ctr" lIns="54864" rIns="54864" tIns="36576" bIns="36576"/>
+          <a:bodyPr lIns="54864" tIns="36576" rIns="54864" bIns="36576" rtlCol="0" anchor="ctr"/>
           <a:lstStyle/>
           <a:p>
             <a:pPr algn="ctr"/>
             <a:r>
-              <a:rPr sz="850" b="1">
+              <a:rPr sz="850" b="1" dirty="0">
                 <a:solidFill>
                   <a:srgbClr val="172033"/>
                 </a:solidFill>
@@ -3221,7 +3660,7 @@
           <a:p>
             <a:pPr algn="ctr"/>
             <a:r>
-              <a:rPr sz="650" b="0">
+              <a:rPr sz="650" b="0" dirty="0">
                 <a:solidFill>
                   <a:srgbClr val="64748B"/>
                 </a:solidFill>
@@ -3274,6 +3713,7 @@
           <a:lstStyle/>
           <a:p>
             <a:pPr algn="ctr"/>
+            <a:endParaRPr dirty="0"/>
           </a:p>
         </p:txBody>
       </p:sp>
@@ -3294,14 +3734,14 @@
           <a:noFill/>
         </p:spPr>
         <p:txBody>
-          <a:bodyPr wrap="none" lIns="54864" rIns="54864" tIns="36576" bIns="36576">
+          <a:bodyPr wrap="none" lIns="54864" tIns="36576" rIns="54864" bIns="36576">
             <a:spAutoFit/>
           </a:bodyPr>
           <a:lstStyle/>
           <a:p>
             <a:pPr algn="ctr"/>
             <a:r>
-              <a:rPr sz="650" b="1">
+              <a:rPr sz="650" b="1" dirty="0">
                 <a:solidFill>
                   <a:srgbClr val="2563EB"/>
                 </a:solidFill>
@@ -3354,6 +3794,7 @@
           <a:lstStyle/>
           <a:p>
             <a:pPr algn="ctr"/>
+            <a:endParaRPr dirty="0"/>
           </a:p>
         </p:txBody>
       </p:sp>
@@ -3374,14 +3815,14 @@
           <a:noFill/>
         </p:spPr>
         <p:txBody>
-          <a:bodyPr wrap="none" lIns="54864" rIns="54864" tIns="36576" bIns="36576">
+          <a:bodyPr wrap="none" lIns="54864" tIns="36576" rIns="54864" bIns="36576">
             <a:spAutoFit/>
           </a:bodyPr>
           <a:lstStyle/>
           <a:p>
             <a:pPr algn="ctr"/>
             <a:r>
-              <a:rPr sz="650" b="1">
+              <a:rPr sz="650" b="1" dirty="0">
                 <a:solidFill>
                   <a:srgbClr val="15803D"/>
                 </a:solidFill>
@@ -3434,6 +3875,7 @@
           <a:lstStyle/>
           <a:p>
             <a:pPr algn="ctr"/>
+            <a:endParaRPr dirty="0"/>
           </a:p>
         </p:txBody>
       </p:sp>
@@ -3454,14 +3896,14 @@
           <a:noFill/>
         </p:spPr>
         <p:txBody>
-          <a:bodyPr wrap="none" lIns="54864" rIns="54864" tIns="36576" bIns="36576">
+          <a:bodyPr wrap="none" lIns="54864" tIns="36576" rIns="54864" bIns="36576">
             <a:spAutoFit/>
           </a:bodyPr>
           <a:lstStyle/>
           <a:p>
             <a:pPr algn="ctr"/>
             <a:r>
-              <a:rPr sz="650" b="1">
+              <a:rPr sz="650" b="1" dirty="0">
                 <a:solidFill>
                   <a:srgbClr val="B7791F"/>
                 </a:solidFill>
@@ -3514,6 +3956,7 @@
           <a:lstStyle/>
           <a:p>
             <a:pPr algn="ctr"/>
+            <a:endParaRPr dirty="0"/>
           </a:p>
         </p:txBody>
       </p:sp>
@@ -3534,14 +3977,14 @@
           <a:noFill/>
         </p:spPr>
         <p:txBody>
-          <a:bodyPr wrap="none" lIns="54864" rIns="54864" tIns="36576" bIns="36576">
+          <a:bodyPr wrap="none" lIns="54864" tIns="36576" rIns="54864" bIns="36576">
             <a:spAutoFit/>
           </a:bodyPr>
           <a:lstStyle/>
           <a:p>
             <a:pPr algn="ctr"/>
             <a:r>
-              <a:rPr sz="650" b="1">
+              <a:rPr sz="650" b="1" dirty="0">
                 <a:solidFill>
                   <a:srgbClr val="0F766E"/>
                 </a:solidFill>
@@ -3594,6 +4037,7 @@
           <a:lstStyle/>
           <a:p>
             <a:pPr algn="ctr"/>
+            <a:endParaRPr dirty="0"/>
           </a:p>
         </p:txBody>
       </p:sp>
@@ -3614,14 +4058,14 @@
           <a:noFill/>
         </p:spPr>
         <p:txBody>
-          <a:bodyPr wrap="none" lIns="54864" rIns="54864" tIns="36576" bIns="36576">
+          <a:bodyPr wrap="none" lIns="54864" tIns="36576" rIns="54864" bIns="36576">
             <a:spAutoFit/>
           </a:bodyPr>
           <a:lstStyle/>
           <a:p>
             <a:pPr algn="ctr"/>
             <a:r>
-              <a:rPr sz="650" b="1">
+              <a:rPr sz="650" b="1" dirty="0">
                 <a:solidFill>
                   <a:srgbClr val="6D28D9"/>
                 </a:solidFill>
@@ -3670,12 +4114,12 @@
           </a:fontRef>
         </p:style>
         <p:txBody>
-          <a:bodyPr rtlCol="0" anchor="ctr" lIns="54864" rIns="54864" tIns="36576" bIns="36576"/>
+          <a:bodyPr lIns="54864" tIns="36576" rIns="54864" bIns="36576" rtlCol="0" anchor="ctr"/>
           <a:lstStyle/>
           <a:p>
             <a:pPr algn="ctr"/>
             <a:r>
-              <a:rPr sz="780" b="1">
+              <a:rPr sz="780" b="1" dirty="0">
                 <a:solidFill>
                   <a:srgbClr val="172033"/>
                 </a:solidFill>
@@ -3687,7 +4131,7 @@
           <a:p>
             <a:pPr algn="ctr"/>
             <a:r>
-              <a:rPr sz="600" b="0">
+              <a:rPr sz="600" b="0" dirty="0" err="1">
                 <a:solidFill>
                   <a:srgbClr val="64748B"/>
                 </a:solidFill>
@@ -3695,6 +4139,12 @@
               </a:rPr>
               <a:t>q,o,c,h,r,v</a:t>
             </a:r>
+            <a:endParaRPr sz="600" b="0">
+              <a:solidFill>
+                <a:srgbClr val="64748B"/>
+              </a:solidFill>
+              <a:latin typeface="Aptos"/>
+            </a:endParaRPr>
           </a:p>
         </p:txBody>
       </p:sp>
@@ -3736,7 +4186,7 @@
           </a:fontRef>
         </p:style>
         <p:txBody>
-          <a:bodyPr rtlCol="0" anchor="ctr" lIns="54864" rIns="54864" tIns="36576" bIns="36576"/>
+          <a:bodyPr lIns="54864" tIns="36576" rIns="54864" bIns="36576" rtlCol="0" anchor="ctr"/>
           <a:lstStyle/>
           <a:p>
             <a:pPr algn="ctr"/>
@@ -3802,7 +4252,7 @@
           </a:fontRef>
         </p:style>
         <p:txBody>
-          <a:bodyPr rtlCol="0" anchor="ctr" lIns="54864" rIns="54864" tIns="36576" bIns="36576"/>
+          <a:bodyPr lIns="54864" tIns="36576" rIns="54864" bIns="36576" rtlCol="0" anchor="ctr"/>
           <a:lstStyle/>
           <a:p>
             <a:pPr algn="ctr"/>
@@ -3868,7 +4318,7 @@
           </a:fontRef>
         </p:style>
         <p:txBody>
-          <a:bodyPr rtlCol="0" anchor="ctr" lIns="54864" rIns="54864" tIns="36576" bIns="36576"/>
+          <a:bodyPr lIns="54864" tIns="36576" rIns="54864" bIns="36576" rtlCol="0" anchor="ctr"/>
           <a:lstStyle/>
           <a:p>
             <a:pPr algn="ctr"/>
@@ -4039,7 +4489,7 @@
           </a:fontRef>
         </p:style>
         <p:txBody>
-          <a:bodyPr rtlCol="0" anchor="ctr" lIns="54864" rIns="54864" tIns="36576" bIns="36576"/>
+          <a:bodyPr lIns="54864" tIns="36576" rIns="54864" bIns="36576" rtlCol="0" anchor="ctr"/>
           <a:lstStyle/>
           <a:p>
             <a:pPr algn="ctr"/>
@@ -4105,7 +4555,7 @@
           </a:fontRef>
         </p:style>
         <p:txBody>
-          <a:bodyPr rtlCol="0" anchor="ctr" lIns="54864" rIns="54864" tIns="36576" bIns="36576"/>
+          <a:bodyPr lIns="54864" tIns="36576" rIns="54864" bIns="36576" rtlCol="0" anchor="ctr"/>
           <a:lstStyle/>
           <a:p>
             <a:pPr algn="ctr"/>
@@ -4183,7 +4633,7 @@
           </a:fontRef>
         </p:style>
         <p:txBody>
-          <a:bodyPr rtlCol="0" anchor="ctr" lIns="54864" rIns="54864" tIns="36576" bIns="36576"/>
+          <a:bodyPr lIns="54864" tIns="36576" rIns="54864" bIns="36576" rtlCol="0" anchor="ctr"/>
           <a:lstStyle/>
           <a:p>
             <a:pPr algn="ctr"/>
@@ -4249,7 +4699,7 @@
           </a:fontRef>
         </p:style>
         <p:txBody>
-          <a:bodyPr rtlCol="0" anchor="ctr" lIns="54864" rIns="54864" tIns="36576" bIns="36576"/>
+          <a:bodyPr lIns="54864" tIns="36576" rIns="54864" bIns="36576" rtlCol="0" anchor="ctr"/>
           <a:lstStyle/>
           <a:p>
             <a:pPr algn="ctr"/>
@@ -4315,7 +4765,7 @@
           </a:fontRef>
         </p:style>
         <p:txBody>
-          <a:bodyPr rtlCol="0" anchor="ctr" lIns="54864" rIns="54864" tIns="36576" bIns="36576"/>
+          <a:bodyPr lIns="54864" tIns="36576" rIns="54864" bIns="36576" rtlCol="0" anchor="ctr"/>
           <a:lstStyle/>
           <a:p>
             <a:pPr algn="ctr"/>
@@ -4393,7 +4843,7 @@
           </a:fontRef>
         </p:style>
         <p:txBody>
-          <a:bodyPr rtlCol="0" anchor="ctr" lIns="54864" rIns="54864" tIns="36576" bIns="36576"/>
+          <a:bodyPr lIns="54864" tIns="36576" rIns="54864" bIns="36576" rtlCol="0" anchor="ctr"/>
           <a:lstStyle/>
           <a:p>
             <a:pPr algn="ctr"/>
@@ -4438,7 +4888,7 @@
           <a:noFill/>
         </p:spPr>
         <p:txBody>
-          <a:bodyPr wrap="none" lIns="54864" rIns="54864" tIns="36576" bIns="36576">
+          <a:bodyPr wrap="none" lIns="54864" tIns="36576" rIns="54864" bIns="36576">
             <a:spAutoFit/>
           </a:bodyPr>
           <a:lstStyle/>
@@ -5342,7 +5792,7 @@
           </a:fontRef>
         </p:style>
         <p:txBody>
-          <a:bodyPr rtlCol="0" anchor="ctr" lIns="54864" rIns="54864" tIns="36576" bIns="36576"/>
+          <a:bodyPr lIns="54864" tIns="36576" rIns="54864" bIns="36576" rtlCol="0" anchor="ctr"/>
           <a:lstStyle/>
           <a:p>
             <a:pPr algn="ctr"/>
@@ -5408,7 +5858,7 @@
           </a:fontRef>
         </p:style>
         <p:txBody>
-          <a:bodyPr rtlCol="0" anchor="ctr" lIns="54864" rIns="54864" tIns="36576" bIns="36576"/>
+          <a:bodyPr lIns="54864" tIns="36576" rIns="54864" bIns="36576" rtlCol="0" anchor="ctr"/>
           <a:lstStyle/>
           <a:p>
             <a:pPr algn="ctr"/>
@@ -5465,7 +5915,7 @@
           <a:noFill/>
         </p:spPr>
         <p:txBody>
-          <a:bodyPr wrap="none" lIns="54864" rIns="54864" tIns="36576" bIns="36576">
+          <a:bodyPr wrap="none" lIns="54864" tIns="36576" rIns="54864" bIns="36576">
             <a:spAutoFit/>
           </a:bodyPr>
           <a:lstStyle/>
@@ -5592,7 +6042,7 @@
           </a:fontRef>
         </p:style>
         <p:txBody>
-          <a:bodyPr rtlCol="0" anchor="ctr" lIns="54864" rIns="54864" tIns="36576" bIns="36576"/>
+          <a:bodyPr lIns="54864" tIns="36576" rIns="54864" bIns="36576" rtlCol="0" anchor="ctr"/>
           <a:lstStyle/>
           <a:p>
             <a:pPr algn="ctr"/>
@@ -5658,7 +6108,7 @@
           </a:fontRef>
         </p:style>
         <p:txBody>
-          <a:bodyPr rtlCol="0" anchor="ctr" lIns="54864" rIns="54864" tIns="36576" bIns="36576"/>
+          <a:bodyPr lIns="54864" tIns="36576" rIns="54864" bIns="36576" rtlCol="0" anchor="ctr"/>
           <a:lstStyle/>
           <a:p>
             <a:pPr algn="ctr"/>
@@ -5724,7 +6174,7 @@
           </a:fontRef>
         </p:style>
         <p:txBody>
-          <a:bodyPr rtlCol="0" anchor="ctr" lIns="54864" rIns="54864" tIns="36576" bIns="36576"/>
+          <a:bodyPr lIns="54864" tIns="36576" rIns="54864" bIns="36576" rtlCol="0" anchor="ctr"/>
           <a:lstStyle/>
           <a:p>
             <a:pPr algn="ctr"/>
@@ -5790,7 +6240,7 @@
           </a:fontRef>
         </p:style>
         <p:txBody>
-          <a:bodyPr rtlCol="0" anchor="ctr" lIns="54864" rIns="54864" tIns="36576" bIns="36576"/>
+          <a:bodyPr lIns="54864" tIns="36576" rIns="54864" bIns="36576" rtlCol="0" anchor="ctr"/>
           <a:lstStyle/>
           <a:p>
             <a:pPr algn="ctr"/>
@@ -6101,7 +6551,7 @@
           </a:fontRef>
         </p:style>
         <p:txBody>
-          <a:bodyPr rtlCol="0" anchor="ctr" lIns="54864" rIns="54864" tIns="36576" bIns="36576"/>
+          <a:bodyPr lIns="54864" tIns="36576" rIns="54864" bIns="36576" rtlCol="0" anchor="ctr"/>
           <a:lstStyle/>
           <a:p>
             <a:pPr algn="ctr"/>
@@ -6167,7 +6617,7 @@
           </a:fontRef>
         </p:style>
         <p:txBody>
-          <a:bodyPr rtlCol="0" anchor="ctr" lIns="54864" rIns="54864" tIns="36576" bIns="36576"/>
+          <a:bodyPr lIns="54864" tIns="36576" rIns="54864" bIns="36576" rtlCol="0" anchor="ctr"/>
           <a:lstStyle/>
           <a:p>
             <a:pPr algn="ctr"/>
@@ -6233,7 +6683,7 @@
           </a:fontRef>
         </p:style>
         <p:txBody>
-          <a:bodyPr rtlCol="0" anchor="ctr" lIns="54864" rIns="54864" tIns="36576" bIns="36576"/>
+          <a:bodyPr lIns="54864" tIns="36576" rIns="54864" bIns="36576" rtlCol="0" anchor="ctr"/>
           <a:lstStyle/>
           <a:p>
             <a:pPr algn="ctr"/>
@@ -6311,7 +6761,7 @@
           </a:fontRef>
         </p:style>
         <p:txBody>
-          <a:bodyPr rtlCol="0" anchor="ctr" lIns="54864" rIns="54864" tIns="36576" bIns="36576"/>
+          <a:bodyPr lIns="54864" tIns="36576" rIns="54864" bIns="36576" rtlCol="0" anchor="ctr"/>
           <a:lstStyle/>
           <a:p>
             <a:pPr algn="ctr"/>
@@ -6377,7 +6827,7 @@
           </a:fontRef>
         </p:style>
         <p:txBody>
-          <a:bodyPr rtlCol="0" anchor="ctr" lIns="54864" rIns="54864" tIns="36576" bIns="36576"/>
+          <a:bodyPr lIns="54864" tIns="36576" rIns="54864" bIns="36576" rtlCol="0" anchor="ctr"/>
           <a:lstStyle/>
           <a:p>
             <a:pPr algn="ctr"/>
@@ -6953,7 +7403,7 @@
           <a:noFill/>
         </p:spPr>
         <p:txBody>
-          <a:bodyPr wrap="none" lIns="54864" rIns="54864" tIns="36576" bIns="36576">
+          <a:bodyPr wrap="none" lIns="54864" tIns="36576" rIns="54864" bIns="36576">
             <a:spAutoFit/>
           </a:bodyPr>
           <a:lstStyle/>
@@ -7079,7 +7529,7 @@
           </a:fontRef>
         </p:style>
         <p:txBody>
-          <a:bodyPr rtlCol="0" anchor="ctr" lIns="54864" rIns="54864" tIns="36576" bIns="36576"/>
+          <a:bodyPr lIns="54864" tIns="36576" rIns="54864" bIns="36576" rtlCol="0" anchor="ctr"/>
           <a:lstStyle/>
           <a:p>
             <a:pPr algn="ctr"/>
@@ -7133,7 +7583,7 @@
           </a:fontRef>
         </p:style>
         <p:txBody>
-          <a:bodyPr rtlCol="0" anchor="ctr" lIns="54864" rIns="54864" tIns="36576" bIns="36576"/>
+          <a:bodyPr lIns="54864" tIns="36576" rIns="54864" bIns="36576" rtlCol="0" anchor="ctr"/>
           <a:lstStyle/>
           <a:p>
             <a:pPr algn="ctr"/>
@@ -7166,7 +7616,7 @@
           <a:noFill/>
         </p:spPr>
         <p:txBody>
-          <a:bodyPr wrap="none" lIns="54864" rIns="54864" tIns="36576" bIns="36576">
+          <a:bodyPr wrap="none" lIns="54864" tIns="36576" rIns="54864" bIns="36576">
             <a:spAutoFit/>
           </a:bodyPr>
           <a:lstStyle/>
@@ -7185,6 +7635,1677 @@
         </p:txBody>
       </p:sp>
     </p:spTree>
+  </p:cSld>
+  <p:clrMapOvr>
+    <a:masterClrMapping/>
+  </p:clrMapOvr>
+</p:sld>
+</file>
+
+<file path=ppt/slides/slide2.xml><?xml version="1.0" encoding="utf-8"?>
+<p:sld xmlns:a="http://schemas.openxmlformats.org/drawingml/2006/main" xmlns:r="http://schemas.openxmlformats.org/officeDocument/2006/relationships" xmlns:p="http://schemas.openxmlformats.org/presentationml/2006/main">
+  <p:cSld>
+    <p:spTree>
+      <p:nvGrpSpPr>
+        <p:cNvPr id="1" name=""/>
+        <p:cNvGrpSpPr/>
+        <p:nvPr/>
+      </p:nvGrpSpPr>
+      <p:grpSpPr>
+        <a:xfrm>
+          <a:off x="0" y="0"/>
+          <a:ext cx="0" cy="0"/>
+          <a:chOff x="0" y="0"/>
+          <a:chExt cx="0" cy="0"/>
+        </a:xfrm>
+      </p:grpSpPr>
+      <p:grpSp>
+        <p:nvGrpSpPr>
+          <p:cNvPr id="126" name="Group 125">
+            <a:extLst>
+              <a:ext uri="{FF2B5EF4-FFF2-40B4-BE49-F238E27FC236}">
+                <a16:creationId xmlns:a16="http://schemas.microsoft.com/office/drawing/2014/main" id="{DA1105BF-FC84-F1C8-2711-3DF11E64C3E6}"/>
+              </a:ext>
+            </a:extLst>
+          </p:cNvPr>
+          <p:cNvGrpSpPr/>
+          <p:nvPr/>
+        </p:nvGrpSpPr>
+        <p:grpSpPr>
+          <a:xfrm>
+            <a:off x="4284076" y="2738725"/>
+            <a:ext cx="1753565" cy="1442599"/>
+            <a:chOff x="4377713" y="208551"/>
+            <a:chExt cx="1753565" cy="1442599"/>
+          </a:xfrm>
+        </p:grpSpPr>
+        <p:grpSp>
+          <p:nvGrpSpPr>
+            <p:cNvPr id="115" name="Group 114">
+              <a:extLst>
+                <a:ext uri="{FF2B5EF4-FFF2-40B4-BE49-F238E27FC236}">
+                  <a16:creationId xmlns:a16="http://schemas.microsoft.com/office/drawing/2014/main" id="{40763740-929A-1D37-5C76-01102163877F}"/>
+                </a:ext>
+              </a:extLst>
+            </p:cNvPr>
+            <p:cNvGrpSpPr/>
+            <p:nvPr/>
+          </p:nvGrpSpPr>
+          <p:grpSpPr>
+            <a:xfrm>
+              <a:off x="4909370" y="208551"/>
+              <a:ext cx="690254" cy="1164614"/>
+              <a:chOff x="4133867" y="83835"/>
+              <a:chExt cx="690254" cy="1164614"/>
+            </a:xfrm>
+          </p:grpSpPr>
+          <p:pic>
+            <p:nvPicPr>
+              <p:cNvPr id="111" name="Picture 110" descr="A black background with a black square&#10;&#10;AI-generated content may be incorrect.">
+                <a:extLst>
+                  <a:ext uri="{FF2B5EF4-FFF2-40B4-BE49-F238E27FC236}">
+                    <a16:creationId xmlns:a16="http://schemas.microsoft.com/office/drawing/2014/main" id="{FCF102CA-C703-A267-85A9-9AAC778A028A}"/>
+                  </a:ext>
+                </a:extLst>
+              </p:cNvPr>
+              <p:cNvPicPr>
+                <a:picLocks noChangeAspect="1"/>
+              </p:cNvPicPr>
+              <p:nvPr/>
+            </p:nvPicPr>
+            <p:blipFill>
+              <a:blip r:embed="rId3"/>
+              <a:stretch>
+                <a:fillRect/>
+              </a:stretch>
+            </p:blipFill>
+            <p:spPr>
+              <a:xfrm>
+                <a:off x="4133867" y="558195"/>
+                <a:ext cx="690254" cy="690254"/>
+              </a:xfrm>
+              <a:prstGeom prst="rect">
+                <a:avLst/>
+              </a:prstGeom>
+            </p:spPr>
+          </p:pic>
+          <p:pic>
+            <p:nvPicPr>
+              <p:cNvPr id="114" name="Picture 113" descr="A black background with a black square&#10;&#10;AI-generated content may be incorrect.">
+                <a:extLst>
+                  <a:ext uri="{FF2B5EF4-FFF2-40B4-BE49-F238E27FC236}">
+                    <a16:creationId xmlns:a16="http://schemas.microsoft.com/office/drawing/2014/main" id="{A6782EEF-8D9A-F262-FBD6-557007C74BE1}"/>
+                  </a:ext>
+                </a:extLst>
+              </p:cNvPr>
+              <p:cNvPicPr>
+                <a:picLocks noChangeAspect="1"/>
+              </p:cNvPicPr>
+              <p:nvPr/>
+            </p:nvPicPr>
+            <p:blipFill>
+              <a:blip r:embed="rId4"/>
+              <a:stretch>
+                <a:fillRect/>
+              </a:stretch>
+            </p:blipFill>
+            <p:spPr>
+              <a:xfrm>
+                <a:off x="4151372" y="83835"/>
+                <a:ext cx="571175" cy="571175"/>
+              </a:xfrm>
+              <a:prstGeom prst="rect">
+                <a:avLst/>
+              </a:prstGeom>
+            </p:spPr>
+          </p:pic>
+        </p:grpSp>
+        <p:sp>
+          <p:nvSpPr>
+            <p:cNvPr id="120" name="TextBox 119">
+              <a:extLst>
+                <a:ext uri="{FF2B5EF4-FFF2-40B4-BE49-F238E27FC236}">
+                  <a16:creationId xmlns:a16="http://schemas.microsoft.com/office/drawing/2014/main" id="{8D43051A-DE3F-C95B-1191-C5444D0D2E6D}"/>
+                </a:ext>
+              </a:extLst>
+            </p:cNvPr>
+            <p:cNvSpPr txBox="1"/>
+            <p:nvPr/>
+          </p:nvSpPr>
+          <p:spPr>
+            <a:xfrm>
+              <a:off x="4377713" y="1281818"/>
+              <a:ext cx="1753565" cy="369332"/>
+            </a:xfrm>
+            <a:prstGeom prst="rect">
+              <a:avLst/>
+            </a:prstGeom>
+            <a:noFill/>
+          </p:spPr>
+          <p:txBody>
+            <a:bodyPr wrap="square">
+              <a:spAutoFit/>
+            </a:bodyPr>
+            <a:lstStyle/>
+            <a:p>
+              <a:pPr algn="ctr"/>
+              <a:r>
+                <a:rPr lang="en-US" dirty="0"/>
+                <a:t>Planner Agent</a:t>
+              </a:r>
+            </a:p>
+          </p:txBody>
+        </p:sp>
+      </p:grpSp>
+      <p:grpSp>
+        <p:nvGrpSpPr>
+          <p:cNvPr id="127" name="Group 126">
+            <a:extLst>
+              <a:ext uri="{FF2B5EF4-FFF2-40B4-BE49-F238E27FC236}">
+                <a16:creationId xmlns:a16="http://schemas.microsoft.com/office/drawing/2014/main" id="{9EC12172-276E-31C6-1F5F-03C8011615D8}"/>
+              </a:ext>
+            </a:extLst>
+          </p:cNvPr>
+          <p:cNvGrpSpPr/>
+          <p:nvPr/>
+        </p:nvGrpSpPr>
+        <p:grpSpPr>
+          <a:xfrm>
+            <a:off x="4273967" y="4099575"/>
+            <a:ext cx="1753565" cy="1447667"/>
+            <a:chOff x="4377713" y="1870304"/>
+            <a:chExt cx="1753565" cy="1447667"/>
+          </a:xfrm>
+        </p:grpSpPr>
+        <p:grpSp>
+          <p:nvGrpSpPr>
+            <p:cNvPr id="118" name="Group 117">
+              <a:extLst>
+                <a:ext uri="{FF2B5EF4-FFF2-40B4-BE49-F238E27FC236}">
+                  <a16:creationId xmlns:a16="http://schemas.microsoft.com/office/drawing/2014/main" id="{B73BFD2B-9489-7016-4FB3-9DCCF8BFC9EE}"/>
+                </a:ext>
+              </a:extLst>
+            </p:cNvPr>
+            <p:cNvGrpSpPr/>
+            <p:nvPr/>
+          </p:nvGrpSpPr>
+          <p:grpSpPr>
+            <a:xfrm>
+              <a:off x="4926875" y="1870304"/>
+              <a:ext cx="671567" cy="1098936"/>
+              <a:chOff x="4132078" y="2516824"/>
+              <a:chExt cx="671567" cy="1098936"/>
+            </a:xfrm>
+          </p:grpSpPr>
+          <p:pic>
+            <p:nvPicPr>
+              <p:cNvPr id="105" name="Picture 104" descr="A black background with a black square&#10;&#10;AI-generated content may be incorrect.">
+                <a:extLst>
+                  <a:ext uri="{FF2B5EF4-FFF2-40B4-BE49-F238E27FC236}">
+                    <a16:creationId xmlns:a16="http://schemas.microsoft.com/office/drawing/2014/main" id="{2CB064F4-42AF-45D0-C860-7AFF46965EBA}"/>
+                  </a:ext>
+                </a:extLst>
+              </p:cNvPr>
+              <p:cNvPicPr>
+                <a:picLocks noChangeAspect="1"/>
+              </p:cNvPicPr>
+              <p:nvPr/>
+            </p:nvPicPr>
+            <p:blipFill>
+              <a:blip r:embed="rId5"/>
+              <a:stretch>
+                <a:fillRect/>
+              </a:stretch>
+            </p:blipFill>
+            <p:spPr>
+              <a:xfrm>
+                <a:off x="4232470" y="3044585"/>
+                <a:ext cx="571175" cy="571175"/>
+              </a:xfrm>
+              <a:prstGeom prst="rect">
+                <a:avLst/>
+              </a:prstGeom>
+            </p:spPr>
+          </p:pic>
+          <p:pic>
+            <p:nvPicPr>
+              <p:cNvPr id="113" name="Picture 112" descr="A black background with a black square&#10;&#10;AI-generated content may be incorrect.">
+                <a:extLst>
+                  <a:ext uri="{FF2B5EF4-FFF2-40B4-BE49-F238E27FC236}">
+                    <a16:creationId xmlns:a16="http://schemas.microsoft.com/office/drawing/2014/main" id="{6845757B-B02C-CB26-2573-7AC066FE8008}"/>
+                  </a:ext>
+                </a:extLst>
+              </p:cNvPr>
+              <p:cNvPicPr>
+                <a:picLocks noChangeAspect="1"/>
+              </p:cNvPicPr>
+              <p:nvPr/>
+            </p:nvPicPr>
+            <p:blipFill>
+              <a:blip r:embed="rId4"/>
+              <a:stretch>
+                <a:fillRect/>
+              </a:stretch>
+            </p:blipFill>
+            <p:spPr>
+              <a:xfrm>
+                <a:off x="4132078" y="2516824"/>
+                <a:ext cx="571175" cy="571175"/>
+              </a:xfrm>
+              <a:prstGeom prst="rect">
+                <a:avLst/>
+              </a:prstGeom>
+            </p:spPr>
+          </p:pic>
+        </p:grpSp>
+        <p:sp>
+          <p:nvSpPr>
+            <p:cNvPr id="122" name="TextBox 121">
+              <a:extLst>
+                <a:ext uri="{FF2B5EF4-FFF2-40B4-BE49-F238E27FC236}">
+                  <a16:creationId xmlns:a16="http://schemas.microsoft.com/office/drawing/2014/main" id="{746A4642-70AA-6D9A-BF65-4B093561E9AF}"/>
+                </a:ext>
+              </a:extLst>
+            </p:cNvPr>
+            <p:cNvSpPr txBox="1"/>
+            <p:nvPr/>
+          </p:nvSpPr>
+          <p:spPr>
+            <a:xfrm>
+              <a:off x="4377713" y="2948639"/>
+              <a:ext cx="1753565" cy="369332"/>
+            </a:xfrm>
+            <a:prstGeom prst="rect">
+              <a:avLst/>
+            </a:prstGeom>
+            <a:noFill/>
+          </p:spPr>
+          <p:txBody>
+            <a:bodyPr wrap="square">
+              <a:spAutoFit/>
+            </a:bodyPr>
+            <a:lstStyle/>
+            <a:p>
+              <a:pPr algn="ctr"/>
+              <a:r>
+                <a:rPr lang="en-US" dirty="0"/>
+                <a:t>Criteria Agent</a:t>
+              </a:r>
+            </a:p>
+          </p:txBody>
+        </p:sp>
+      </p:grpSp>
+      <p:grpSp>
+        <p:nvGrpSpPr>
+          <p:cNvPr id="128" name="Group 127">
+            <a:extLst>
+              <a:ext uri="{FF2B5EF4-FFF2-40B4-BE49-F238E27FC236}">
+                <a16:creationId xmlns:a16="http://schemas.microsoft.com/office/drawing/2014/main" id="{788539DD-1B46-8824-CA78-EEEE04A39BE0}"/>
+              </a:ext>
+            </a:extLst>
+          </p:cNvPr>
+          <p:cNvGrpSpPr/>
+          <p:nvPr/>
+        </p:nvGrpSpPr>
+        <p:grpSpPr>
+          <a:xfrm>
+            <a:off x="4284076" y="5501901"/>
+            <a:ext cx="1753565" cy="1325454"/>
+            <a:chOff x="4436071" y="3437667"/>
+            <a:chExt cx="1753565" cy="1325454"/>
+          </a:xfrm>
+        </p:grpSpPr>
+        <p:grpSp>
+          <p:nvGrpSpPr>
+            <p:cNvPr id="117" name="Group 116">
+              <a:extLst>
+                <a:ext uri="{FF2B5EF4-FFF2-40B4-BE49-F238E27FC236}">
+                  <a16:creationId xmlns:a16="http://schemas.microsoft.com/office/drawing/2014/main" id="{FC43135F-B72B-CC96-B20F-A49E37E297E8}"/>
+                </a:ext>
+              </a:extLst>
+            </p:cNvPr>
+            <p:cNvGrpSpPr/>
+            <p:nvPr/>
+          </p:nvGrpSpPr>
+          <p:grpSpPr>
+            <a:xfrm>
+              <a:off x="4968909" y="3437667"/>
+              <a:ext cx="571175" cy="956122"/>
+              <a:chOff x="3316211" y="3167655"/>
+              <a:chExt cx="571175" cy="956122"/>
+            </a:xfrm>
+          </p:grpSpPr>
+          <p:pic>
+            <p:nvPicPr>
+              <p:cNvPr id="107" name="Picture 106" descr="A black background with a black square&#10;&#10;AI-generated content may be incorrect.">
+                <a:extLst>
+                  <a:ext uri="{FF2B5EF4-FFF2-40B4-BE49-F238E27FC236}">
+                    <a16:creationId xmlns:a16="http://schemas.microsoft.com/office/drawing/2014/main" id="{14C0E13E-F69E-1060-056A-15C2ED841715}"/>
+                  </a:ext>
+                </a:extLst>
+              </p:cNvPr>
+              <p:cNvPicPr>
+                <a:picLocks noChangeAspect="1"/>
+              </p:cNvPicPr>
+              <p:nvPr/>
+            </p:nvPicPr>
+            <p:blipFill>
+              <a:blip r:embed="rId6"/>
+              <a:stretch>
+                <a:fillRect/>
+              </a:stretch>
+            </p:blipFill>
+            <p:spPr>
+              <a:xfrm>
+                <a:off x="3433574" y="3690831"/>
+                <a:ext cx="432946" cy="432946"/>
+              </a:xfrm>
+              <a:prstGeom prst="rect">
+                <a:avLst/>
+              </a:prstGeom>
+            </p:spPr>
+          </p:pic>
+          <p:pic>
+            <p:nvPicPr>
+              <p:cNvPr id="116" name="Picture 115" descr="A black background with a black square&#10;&#10;AI-generated content may be incorrect.">
+                <a:extLst>
+                  <a:ext uri="{FF2B5EF4-FFF2-40B4-BE49-F238E27FC236}">
+                    <a16:creationId xmlns:a16="http://schemas.microsoft.com/office/drawing/2014/main" id="{15EACBD4-69B1-C9A4-C9A6-6FE213FCF2C1}"/>
+                  </a:ext>
+                </a:extLst>
+              </p:cNvPr>
+              <p:cNvPicPr>
+                <a:picLocks noChangeAspect="1"/>
+              </p:cNvPicPr>
+              <p:nvPr/>
+            </p:nvPicPr>
+            <p:blipFill>
+              <a:blip r:embed="rId4"/>
+              <a:stretch>
+                <a:fillRect/>
+              </a:stretch>
+            </p:blipFill>
+            <p:spPr>
+              <a:xfrm>
+                <a:off x="3316211" y="3167655"/>
+                <a:ext cx="571175" cy="571175"/>
+              </a:xfrm>
+              <a:prstGeom prst="rect">
+                <a:avLst/>
+              </a:prstGeom>
+            </p:spPr>
+          </p:pic>
+        </p:grpSp>
+        <p:sp>
+          <p:nvSpPr>
+            <p:cNvPr id="124" name="TextBox 123">
+              <a:extLst>
+                <a:ext uri="{FF2B5EF4-FFF2-40B4-BE49-F238E27FC236}">
+                  <a16:creationId xmlns:a16="http://schemas.microsoft.com/office/drawing/2014/main" id="{BA2A015B-0720-FD3D-122D-B5B328C2B2F2}"/>
+                </a:ext>
+              </a:extLst>
+            </p:cNvPr>
+            <p:cNvSpPr txBox="1"/>
+            <p:nvPr/>
+          </p:nvSpPr>
+          <p:spPr>
+            <a:xfrm>
+              <a:off x="4436071" y="4393789"/>
+              <a:ext cx="1753565" cy="369332"/>
+            </a:xfrm>
+            <a:prstGeom prst="rect">
+              <a:avLst/>
+            </a:prstGeom>
+            <a:noFill/>
+          </p:spPr>
+          <p:txBody>
+            <a:bodyPr wrap="square">
+              <a:spAutoFit/>
+            </a:bodyPr>
+            <a:lstStyle/>
+            <a:p>
+              <a:pPr algn="ctr"/>
+              <a:r>
+                <a:rPr lang="en-US" dirty="0"/>
+                <a:t>Diagnosis Agent</a:t>
+              </a:r>
+            </a:p>
+          </p:txBody>
+        </p:sp>
+      </p:grpSp>
+      <p:sp>
+        <p:nvSpPr>
+          <p:cNvPr id="125" name="Rectangle 124">
+            <a:extLst>
+              <a:ext uri="{FF2B5EF4-FFF2-40B4-BE49-F238E27FC236}">
+                <a16:creationId xmlns:a16="http://schemas.microsoft.com/office/drawing/2014/main" id="{F658EA3B-BDF5-E4EB-6BC5-BAFFF2E64496}"/>
+              </a:ext>
+            </a:extLst>
+          </p:cNvPr>
+          <p:cNvSpPr/>
+          <p:nvPr/>
+        </p:nvSpPr>
+        <p:spPr>
+          <a:xfrm>
+            <a:off x="3559031" y="30645"/>
+            <a:ext cx="5558075" cy="2200919"/>
+          </a:xfrm>
+          <a:prstGeom prst="rect">
+            <a:avLst/>
+          </a:prstGeom>
+          <a:solidFill>
+            <a:srgbClr val="FFC000">
+              <a:alpha val="11859"/>
+            </a:srgbClr>
+          </a:solidFill>
+          <a:ln w="3175">
+            <a:solidFill>
+              <a:srgbClr val="000000"/>
+            </a:solidFill>
+          </a:ln>
+          <a:effectLst>
+            <a:outerShdw blurRad="40000" dist="23000" dir="5400000" rotWithShape="0">
+              <a:srgbClr val="000000">
+                <a:alpha val="35000"/>
+              </a:srgbClr>
+            </a:outerShdw>
+            <a:softEdge rad="58016"/>
+          </a:effectLst>
+        </p:spPr>
+        <p:style>
+          <a:lnRef idx="1">
+            <a:schemeClr val="accent1"/>
+          </a:lnRef>
+          <a:fillRef idx="3">
+            <a:schemeClr val="accent1"/>
+          </a:fillRef>
+          <a:effectRef idx="2">
+            <a:schemeClr val="accent1"/>
+          </a:effectRef>
+          <a:fontRef idx="minor">
+            <a:schemeClr val="lt1"/>
+          </a:fontRef>
+        </p:style>
+        <p:txBody>
+          <a:bodyPr rtlCol="0" anchor="ctr"/>
+          <a:lstStyle/>
+          <a:p>
+            <a:pPr algn="ctr"/>
+            <a:endParaRPr lang="en-US" dirty="0"/>
+          </a:p>
+        </p:txBody>
+      </p:sp>
+      <p:sp>
+        <p:nvSpPr>
+          <p:cNvPr id="129" name="TextBox 128">
+            <a:extLst>
+              <a:ext uri="{FF2B5EF4-FFF2-40B4-BE49-F238E27FC236}">
+                <a16:creationId xmlns:a16="http://schemas.microsoft.com/office/drawing/2014/main" id="{D464D758-7672-500D-C426-18850BC1CF24}"/>
+              </a:ext>
+            </a:extLst>
+          </p:cNvPr>
+          <p:cNvSpPr txBox="1"/>
+          <p:nvPr/>
+        </p:nvSpPr>
+        <p:spPr>
+          <a:xfrm>
+            <a:off x="3598674" y="119657"/>
+            <a:ext cx="2448909" cy="461665"/>
+          </a:xfrm>
+          <a:prstGeom prst="rect">
+            <a:avLst/>
+          </a:prstGeom>
+          <a:noFill/>
+        </p:spPr>
+        <p:txBody>
+          <a:bodyPr wrap="square">
+            <a:spAutoFit/>
+          </a:bodyPr>
+          <a:lstStyle/>
+          <a:p>
+            <a:pPr algn="ctr"/>
+            <a:r>
+              <a:rPr lang="en-US" sz="2400" dirty="0"/>
+              <a:t>Supervisor Router</a:t>
+            </a:r>
+          </a:p>
+        </p:txBody>
+      </p:sp>
+      <p:sp>
+        <p:nvSpPr>
+          <p:cNvPr id="130" name="Rectangle 129">
+            <a:extLst>
+              <a:ext uri="{FF2B5EF4-FFF2-40B4-BE49-F238E27FC236}">
+                <a16:creationId xmlns:a16="http://schemas.microsoft.com/office/drawing/2014/main" id="{EB059EDE-E2DA-7980-0001-07F4CD8B47CD}"/>
+              </a:ext>
+            </a:extLst>
+          </p:cNvPr>
+          <p:cNvSpPr/>
+          <p:nvPr/>
+        </p:nvSpPr>
+        <p:spPr>
+          <a:xfrm>
+            <a:off x="3783387" y="1405321"/>
+            <a:ext cx="1552078" cy="405420"/>
+          </a:xfrm>
+          <a:prstGeom prst="rect">
+            <a:avLst/>
+          </a:prstGeom>
+          <a:solidFill>
+            <a:schemeClr val="accent6">
+              <a:lumMod val="60000"/>
+              <a:lumOff val="40000"/>
+              <a:alpha val="49336"/>
+            </a:schemeClr>
+          </a:solidFill>
+          <a:ln>
+            <a:solidFill>
+              <a:srgbClr val="000000"/>
+            </a:solidFill>
+          </a:ln>
+        </p:spPr>
+        <p:style>
+          <a:lnRef idx="1">
+            <a:schemeClr val="accent6"/>
+          </a:lnRef>
+          <a:fillRef idx="3">
+            <a:schemeClr val="accent6"/>
+          </a:fillRef>
+          <a:effectRef idx="2">
+            <a:schemeClr val="accent6"/>
+          </a:effectRef>
+          <a:fontRef idx="minor">
+            <a:schemeClr val="lt1"/>
+          </a:fontRef>
+        </p:style>
+        <p:txBody>
+          <a:bodyPr rtlCol="0" anchor="ctr"/>
+          <a:lstStyle/>
+          <a:p>
+            <a:pPr algn="ctr"/>
+            <a:r>
+              <a:rPr lang="en-US" sz="2400" dirty="0"/>
+              <a:t>Cue Scorer</a:t>
+            </a:r>
+          </a:p>
+        </p:txBody>
+      </p:sp>
+      <p:grpSp>
+        <p:nvGrpSpPr>
+          <p:cNvPr id="138" name="Group 137">
+            <a:extLst>
+              <a:ext uri="{FF2B5EF4-FFF2-40B4-BE49-F238E27FC236}">
+                <a16:creationId xmlns:a16="http://schemas.microsoft.com/office/drawing/2014/main" id="{39143C20-4082-9E0C-0D29-C7127C6CC4E6}"/>
+              </a:ext>
+            </a:extLst>
+          </p:cNvPr>
+          <p:cNvGrpSpPr/>
+          <p:nvPr/>
+        </p:nvGrpSpPr>
+        <p:grpSpPr>
+          <a:xfrm>
+            <a:off x="6193102" y="916200"/>
+            <a:ext cx="2637944" cy="369907"/>
+            <a:chOff x="6129545" y="1134161"/>
+            <a:chExt cx="2637944" cy="369907"/>
+          </a:xfrm>
+        </p:grpSpPr>
+        <p:sp>
+          <p:nvSpPr>
+            <p:cNvPr id="131" name="Rectangle 130">
+              <a:extLst>
+                <a:ext uri="{FF2B5EF4-FFF2-40B4-BE49-F238E27FC236}">
+                  <a16:creationId xmlns:a16="http://schemas.microsoft.com/office/drawing/2014/main" id="{C3E20144-2252-2078-F387-B1318904F0B6}"/>
+                </a:ext>
+              </a:extLst>
+            </p:cNvPr>
+            <p:cNvSpPr/>
+            <p:nvPr/>
+          </p:nvSpPr>
+          <p:spPr>
+            <a:xfrm>
+              <a:off x="6129545" y="1134163"/>
+              <a:ext cx="542756" cy="369905"/>
+            </a:xfrm>
+            <a:prstGeom prst="rect">
+              <a:avLst/>
+            </a:prstGeom>
+            <a:solidFill>
+              <a:srgbClr val="0070C0">
+                <a:alpha val="49336"/>
+              </a:srgbClr>
+            </a:solidFill>
+            <a:ln>
+              <a:solidFill>
+                <a:srgbClr val="000000"/>
+              </a:solidFill>
+            </a:ln>
+          </p:spPr>
+          <p:style>
+            <a:lnRef idx="1">
+              <a:schemeClr val="accent6"/>
+            </a:lnRef>
+            <a:fillRef idx="3">
+              <a:schemeClr val="accent6"/>
+            </a:fillRef>
+            <a:effectRef idx="2">
+              <a:schemeClr val="accent6"/>
+            </a:effectRef>
+            <a:fontRef idx="minor">
+              <a:schemeClr val="lt1"/>
+            </a:fontRef>
+          </p:style>
+          <p:txBody>
+            <a:bodyPr rtlCol="0" anchor="ctr"/>
+            <a:lstStyle/>
+            <a:p>
+              <a:pPr algn="ctr"/>
+              <a:r>
+                <a:rPr lang="en-US" sz="2400" dirty="0"/>
+                <a:t>PL</a:t>
+              </a:r>
+            </a:p>
+          </p:txBody>
+        </p:sp>
+        <p:sp>
+          <p:nvSpPr>
+            <p:cNvPr id="132" name="Rectangle 131">
+              <a:extLst>
+                <a:ext uri="{FF2B5EF4-FFF2-40B4-BE49-F238E27FC236}">
+                  <a16:creationId xmlns:a16="http://schemas.microsoft.com/office/drawing/2014/main" id="{2CAEED49-D074-8334-4739-EC29B6410837}"/>
+                </a:ext>
+              </a:extLst>
+            </p:cNvPr>
+            <p:cNvSpPr/>
+            <p:nvPr/>
+          </p:nvSpPr>
+          <p:spPr>
+            <a:xfrm>
+              <a:off x="6818468" y="1134162"/>
+              <a:ext cx="542756" cy="369905"/>
+            </a:xfrm>
+            <a:prstGeom prst="rect">
+              <a:avLst/>
+            </a:prstGeom>
+            <a:solidFill>
+              <a:schemeClr val="accent4">
+                <a:lumMod val="60000"/>
+                <a:lumOff val="40000"/>
+                <a:alpha val="49336"/>
+              </a:schemeClr>
+            </a:solidFill>
+            <a:ln>
+              <a:solidFill>
+                <a:srgbClr val="000000"/>
+              </a:solidFill>
+            </a:ln>
+          </p:spPr>
+          <p:style>
+            <a:lnRef idx="1">
+              <a:schemeClr val="accent6"/>
+            </a:lnRef>
+            <a:fillRef idx="3">
+              <a:schemeClr val="accent6"/>
+            </a:fillRef>
+            <a:effectRef idx="2">
+              <a:schemeClr val="accent6"/>
+            </a:effectRef>
+            <a:fontRef idx="minor">
+              <a:schemeClr val="lt1"/>
+            </a:fontRef>
+          </p:style>
+          <p:txBody>
+            <a:bodyPr rtlCol="0" anchor="ctr"/>
+            <a:lstStyle/>
+            <a:p>
+              <a:pPr algn="ctr"/>
+              <a:r>
+                <a:rPr lang="en-US" sz="2400" dirty="0"/>
+                <a:t>CF</a:t>
+              </a:r>
+            </a:p>
+          </p:txBody>
+        </p:sp>
+        <p:sp>
+          <p:nvSpPr>
+            <p:cNvPr id="134" name="Rectangle 133">
+              <a:extLst>
+                <a:ext uri="{FF2B5EF4-FFF2-40B4-BE49-F238E27FC236}">
+                  <a16:creationId xmlns:a16="http://schemas.microsoft.com/office/drawing/2014/main" id="{5E923E03-6D7D-DB9B-3871-687C797EA711}"/>
+                </a:ext>
+              </a:extLst>
+            </p:cNvPr>
+            <p:cNvSpPr/>
+            <p:nvPr/>
+          </p:nvSpPr>
+          <p:spPr>
+            <a:xfrm>
+              <a:off x="8196314" y="1134161"/>
+              <a:ext cx="571175" cy="369905"/>
+            </a:xfrm>
+            <a:prstGeom prst="rect">
+              <a:avLst/>
+            </a:prstGeom>
+            <a:solidFill>
+              <a:schemeClr val="accent2">
+                <a:lumMod val="75000"/>
+                <a:alpha val="49336"/>
+              </a:schemeClr>
+            </a:solidFill>
+            <a:ln>
+              <a:solidFill>
+                <a:srgbClr val="000000"/>
+              </a:solidFill>
+            </a:ln>
+          </p:spPr>
+          <p:style>
+            <a:lnRef idx="1">
+              <a:schemeClr val="accent6"/>
+            </a:lnRef>
+            <a:fillRef idx="3">
+              <a:schemeClr val="accent6"/>
+            </a:fillRef>
+            <a:effectRef idx="2">
+              <a:schemeClr val="accent6"/>
+            </a:effectRef>
+            <a:fontRef idx="minor">
+              <a:schemeClr val="lt1"/>
+            </a:fontRef>
+          </p:style>
+          <p:txBody>
+            <a:bodyPr rtlCol="0" anchor="ctr"/>
+            <a:lstStyle/>
+            <a:p>
+              <a:pPr algn="ctr"/>
+              <a:r>
+                <a:rPr lang="en-US" sz="2400" dirty="0"/>
+                <a:t>IM</a:t>
+              </a:r>
+            </a:p>
+          </p:txBody>
+        </p:sp>
+        <p:sp>
+          <p:nvSpPr>
+            <p:cNvPr id="135" name="Rectangle 134">
+              <a:extLst>
+                <a:ext uri="{FF2B5EF4-FFF2-40B4-BE49-F238E27FC236}">
+                  <a16:creationId xmlns:a16="http://schemas.microsoft.com/office/drawing/2014/main" id="{2622F743-9DD7-5C3A-62F1-4870BACB57DD}"/>
+                </a:ext>
+              </a:extLst>
+            </p:cNvPr>
+            <p:cNvSpPr/>
+            <p:nvPr/>
+          </p:nvSpPr>
+          <p:spPr>
+            <a:xfrm>
+              <a:off x="7507391" y="1134162"/>
+              <a:ext cx="542756" cy="369905"/>
+            </a:xfrm>
+            <a:prstGeom prst="rect">
+              <a:avLst/>
+            </a:prstGeom>
+            <a:solidFill>
+              <a:srgbClr val="92D050">
+                <a:alpha val="49336"/>
+              </a:srgbClr>
+            </a:solidFill>
+            <a:ln>
+              <a:solidFill>
+                <a:srgbClr val="000000"/>
+              </a:solidFill>
+            </a:ln>
+          </p:spPr>
+          <p:style>
+            <a:lnRef idx="1">
+              <a:schemeClr val="accent6"/>
+            </a:lnRef>
+            <a:fillRef idx="3">
+              <a:schemeClr val="accent6"/>
+            </a:fillRef>
+            <a:effectRef idx="2">
+              <a:schemeClr val="accent6"/>
+            </a:effectRef>
+            <a:fontRef idx="minor">
+              <a:schemeClr val="lt1"/>
+            </a:fontRef>
+          </p:style>
+          <p:txBody>
+            <a:bodyPr rtlCol="0" anchor="ctr"/>
+            <a:lstStyle/>
+            <a:p>
+              <a:pPr algn="ctr"/>
+              <a:r>
+                <a:rPr lang="en-US" sz="2400" dirty="0"/>
+                <a:t>AR</a:t>
+              </a:r>
+            </a:p>
+          </p:txBody>
+        </p:sp>
+      </p:grpSp>
+      <p:sp>
+        <p:nvSpPr>
+          <p:cNvPr id="96" name="Rectangle 95">
+            <a:extLst>
+              <a:ext uri="{FF2B5EF4-FFF2-40B4-BE49-F238E27FC236}">
+                <a16:creationId xmlns:a16="http://schemas.microsoft.com/office/drawing/2014/main" id="{D912C3CD-EA69-DFB4-7666-F07620371818}"/>
+              </a:ext>
+            </a:extLst>
+          </p:cNvPr>
+          <p:cNvSpPr/>
+          <p:nvPr/>
+        </p:nvSpPr>
+        <p:spPr>
+          <a:xfrm>
+            <a:off x="199897" y="2127004"/>
+            <a:ext cx="1493520" cy="3104586"/>
+          </a:xfrm>
+          <a:prstGeom prst="rect">
+            <a:avLst/>
+          </a:prstGeom>
+          <a:solidFill>
+            <a:srgbClr val="000000">
+              <a:alpha val="14902"/>
+            </a:srgbClr>
+          </a:solidFill>
+          <a:ln>
+            <a:solidFill>
+              <a:srgbClr val="000000"/>
+            </a:solidFill>
+          </a:ln>
+          <a:effectLst>
+            <a:outerShdw blurRad="40000" dist="23000" dir="5400000" rotWithShape="0">
+              <a:srgbClr val="000000">
+                <a:alpha val="35000"/>
+              </a:srgbClr>
+            </a:outerShdw>
+            <a:softEdge rad="58016"/>
+          </a:effectLst>
+        </p:spPr>
+        <p:style>
+          <a:lnRef idx="1">
+            <a:schemeClr val="accent1"/>
+          </a:lnRef>
+          <a:fillRef idx="3">
+            <a:schemeClr val="accent1"/>
+          </a:fillRef>
+          <a:effectRef idx="2">
+            <a:schemeClr val="accent1"/>
+          </a:effectRef>
+          <a:fontRef idx="minor">
+            <a:schemeClr val="lt1"/>
+          </a:fontRef>
+        </p:style>
+        <p:txBody>
+          <a:bodyPr rtlCol="0" anchor="ctr"/>
+          <a:lstStyle/>
+          <a:p>
+            <a:pPr algn="ctr"/>
+            <a:endParaRPr lang="en-US"/>
+          </a:p>
+        </p:txBody>
+      </p:sp>
+      <p:sp>
+        <p:nvSpPr>
+          <p:cNvPr id="137" name="TextBox 136">
+            <a:extLst>
+              <a:ext uri="{FF2B5EF4-FFF2-40B4-BE49-F238E27FC236}">
+                <a16:creationId xmlns:a16="http://schemas.microsoft.com/office/drawing/2014/main" id="{7EBED5D9-D1A0-6EFB-AFA2-55B4E54809C5}"/>
+              </a:ext>
+            </a:extLst>
+          </p:cNvPr>
+          <p:cNvSpPr txBox="1"/>
+          <p:nvPr/>
+        </p:nvSpPr>
+        <p:spPr>
+          <a:xfrm>
+            <a:off x="5785556" y="554942"/>
+            <a:ext cx="3437965" cy="369332"/>
+          </a:xfrm>
+          <a:prstGeom prst="rect">
+            <a:avLst/>
+          </a:prstGeom>
+          <a:noFill/>
+        </p:spPr>
+        <p:txBody>
+          <a:bodyPr wrap="square">
+            <a:spAutoFit/>
+          </a:bodyPr>
+          <a:lstStyle/>
+          <a:p>
+            <a:pPr algn="ctr"/>
+            <a:r>
+              <a:rPr lang="en-US" sz="1800" dirty="0"/>
+              <a:t>Response Regime </a:t>
+            </a:r>
+            <a:r>
+              <a:rPr lang="en-US" dirty="0"/>
+              <a:t>R(x) </a:t>
+            </a:r>
+            <a:r>
+              <a:rPr lang="en-US" sz="1800" dirty="0"/>
+              <a:t>Selection</a:t>
+            </a:r>
+          </a:p>
+        </p:txBody>
+      </p:sp>
+      <p:sp>
+        <p:nvSpPr>
+          <p:cNvPr id="3" name="Rectangle 2">
+            <a:extLst>
+              <a:ext uri="{FF2B5EF4-FFF2-40B4-BE49-F238E27FC236}">
+                <a16:creationId xmlns:a16="http://schemas.microsoft.com/office/drawing/2014/main" id="{D0D7CE50-4421-53F8-F894-185BC86014DF}"/>
+              </a:ext>
+            </a:extLst>
+          </p:cNvPr>
+          <p:cNvSpPr/>
+          <p:nvPr/>
+        </p:nvSpPr>
+        <p:spPr>
+          <a:xfrm>
+            <a:off x="435094" y="2537313"/>
+            <a:ext cx="1034613" cy="299385"/>
+          </a:xfrm>
+          <a:prstGeom prst="rect">
+            <a:avLst/>
+          </a:prstGeom>
+          <a:solidFill>
+            <a:schemeClr val="bg1">
+              <a:lumMod val="50000"/>
+              <a:alpha val="30013"/>
+            </a:schemeClr>
+          </a:solidFill>
+          <a:ln>
+            <a:solidFill>
+              <a:srgbClr val="000000"/>
+            </a:solidFill>
+          </a:ln>
+        </p:spPr>
+        <p:style>
+          <a:lnRef idx="1">
+            <a:schemeClr val="accent6"/>
+          </a:lnRef>
+          <a:fillRef idx="3">
+            <a:schemeClr val="accent6"/>
+          </a:fillRef>
+          <a:effectRef idx="2">
+            <a:schemeClr val="accent6"/>
+          </a:effectRef>
+          <a:fontRef idx="minor">
+            <a:schemeClr val="lt1"/>
+          </a:fontRef>
+        </p:style>
+        <p:txBody>
+          <a:bodyPr rtlCol="0" anchor="ctr"/>
+          <a:lstStyle/>
+          <a:p>
+            <a:pPr algn="ctr"/>
+            <a:r>
+              <a:rPr lang="en-US" dirty="0"/>
+              <a:t>question</a:t>
+            </a:r>
+          </a:p>
+        </p:txBody>
+      </p:sp>
+      <p:sp>
+        <p:nvSpPr>
+          <p:cNvPr id="98" name="TextBox 97">
+            <a:extLst>
+              <a:ext uri="{FF2B5EF4-FFF2-40B4-BE49-F238E27FC236}">
+                <a16:creationId xmlns:a16="http://schemas.microsoft.com/office/drawing/2014/main" id="{B1B557A1-59E1-0D46-73A7-4F04881AD809}"/>
+              </a:ext>
+            </a:extLst>
+          </p:cNvPr>
+          <p:cNvSpPr txBox="1"/>
+          <p:nvPr/>
+        </p:nvSpPr>
+        <p:spPr>
+          <a:xfrm>
+            <a:off x="235460" y="2129859"/>
+            <a:ext cx="1422395" cy="369332"/>
+          </a:xfrm>
+          <a:prstGeom prst="rect">
+            <a:avLst/>
+          </a:prstGeom>
+          <a:noFill/>
+        </p:spPr>
+        <p:txBody>
+          <a:bodyPr wrap="square">
+            <a:spAutoFit/>
+          </a:bodyPr>
+          <a:lstStyle/>
+          <a:p>
+            <a:r>
+              <a:rPr lang="en-US"/>
+              <a:t>Input Entry x</a:t>
+            </a:r>
+          </a:p>
+        </p:txBody>
+      </p:sp>
+      <p:sp>
+        <p:nvSpPr>
+          <p:cNvPr id="99" name="Rectangle 98">
+            <a:extLst>
+              <a:ext uri="{FF2B5EF4-FFF2-40B4-BE49-F238E27FC236}">
+                <a16:creationId xmlns:a16="http://schemas.microsoft.com/office/drawing/2014/main" id="{96A7A591-56D9-2F19-C82E-A32315A0E15F}"/>
+              </a:ext>
+            </a:extLst>
+          </p:cNvPr>
+          <p:cNvSpPr/>
+          <p:nvPr/>
+        </p:nvSpPr>
+        <p:spPr>
+          <a:xfrm>
+            <a:off x="435093" y="2967762"/>
+            <a:ext cx="1034613" cy="299385"/>
+          </a:xfrm>
+          <a:prstGeom prst="rect">
+            <a:avLst/>
+          </a:prstGeom>
+          <a:solidFill>
+            <a:schemeClr val="tx1">
+              <a:lumMod val="85000"/>
+              <a:lumOff val="15000"/>
+              <a:alpha val="51079"/>
+            </a:schemeClr>
+          </a:solidFill>
+          <a:ln>
+            <a:solidFill>
+              <a:srgbClr val="000000"/>
+            </a:solidFill>
+          </a:ln>
+        </p:spPr>
+        <p:style>
+          <a:lnRef idx="1">
+            <a:schemeClr val="accent6"/>
+          </a:lnRef>
+          <a:fillRef idx="3">
+            <a:schemeClr val="accent6"/>
+          </a:fillRef>
+          <a:effectRef idx="2">
+            <a:schemeClr val="accent6"/>
+          </a:effectRef>
+          <a:fontRef idx="minor">
+            <a:schemeClr val="lt1"/>
+          </a:fontRef>
+        </p:style>
+        <p:txBody>
+          <a:bodyPr rtlCol="0" anchor="ctr"/>
+          <a:lstStyle/>
+          <a:p>
+            <a:pPr algn="ctr"/>
+            <a:r>
+              <a:rPr lang="en-US"/>
+              <a:t>options</a:t>
+            </a:r>
+          </a:p>
+        </p:txBody>
+      </p:sp>
+      <p:sp>
+        <p:nvSpPr>
+          <p:cNvPr id="139" name="TextBox 138">
+            <a:extLst>
+              <a:ext uri="{FF2B5EF4-FFF2-40B4-BE49-F238E27FC236}">
+                <a16:creationId xmlns:a16="http://schemas.microsoft.com/office/drawing/2014/main" id="{8FE9B136-27B9-50F3-D293-C66FDD49492E}"/>
+              </a:ext>
+            </a:extLst>
+          </p:cNvPr>
+          <p:cNvSpPr txBox="1"/>
+          <p:nvPr/>
+        </p:nvSpPr>
+        <p:spPr>
+          <a:xfrm>
+            <a:off x="6504041" y="1303369"/>
+            <a:ext cx="2016065" cy="369332"/>
+          </a:xfrm>
+          <a:prstGeom prst="rect">
+            <a:avLst/>
+          </a:prstGeom>
+          <a:noFill/>
+        </p:spPr>
+        <p:txBody>
+          <a:bodyPr wrap="square">
+            <a:spAutoFit/>
+          </a:bodyPr>
+          <a:lstStyle/>
+          <a:p>
+            <a:pPr algn="ctr"/>
+            <a:r>
+              <a:rPr lang="en-US" sz="1800" dirty="0"/>
+              <a:t>Retrieval Gate G(x)</a:t>
+            </a:r>
+          </a:p>
+        </p:txBody>
+      </p:sp>
+      <p:sp>
+        <p:nvSpPr>
+          <p:cNvPr id="100" name="Rectangle 99">
+            <a:extLst>
+              <a:ext uri="{FF2B5EF4-FFF2-40B4-BE49-F238E27FC236}">
+                <a16:creationId xmlns:a16="http://schemas.microsoft.com/office/drawing/2014/main" id="{B6808A9A-3132-CC40-77CD-8D22C1883F24}"/>
+              </a:ext>
+            </a:extLst>
+          </p:cNvPr>
+          <p:cNvSpPr/>
+          <p:nvPr/>
+        </p:nvSpPr>
+        <p:spPr>
+          <a:xfrm>
+            <a:off x="435092" y="3396576"/>
+            <a:ext cx="1034613" cy="299385"/>
+          </a:xfrm>
+          <a:prstGeom prst="rect">
+            <a:avLst/>
+          </a:prstGeom>
+          <a:solidFill>
+            <a:schemeClr val="tx1">
+              <a:lumMod val="85000"/>
+              <a:lumOff val="15000"/>
+              <a:alpha val="51079"/>
+            </a:schemeClr>
+          </a:solidFill>
+          <a:ln>
+            <a:solidFill>
+              <a:srgbClr val="000000"/>
+            </a:solidFill>
+          </a:ln>
+        </p:spPr>
+        <p:style>
+          <a:lnRef idx="1">
+            <a:schemeClr val="accent6"/>
+          </a:lnRef>
+          <a:fillRef idx="3">
+            <a:schemeClr val="accent6"/>
+          </a:fillRef>
+          <a:effectRef idx="2">
+            <a:schemeClr val="accent6"/>
+          </a:effectRef>
+          <a:fontRef idx="minor">
+            <a:schemeClr val="lt1"/>
+          </a:fontRef>
+        </p:style>
+        <p:txBody>
+          <a:bodyPr rtlCol="0" anchor="ctr"/>
+          <a:lstStyle/>
+          <a:p>
+            <a:pPr algn="ctr"/>
+            <a:r>
+              <a:rPr lang="en-US"/>
+              <a:t>context</a:t>
+            </a:r>
+          </a:p>
+        </p:txBody>
+      </p:sp>
+      <p:sp>
+        <p:nvSpPr>
+          <p:cNvPr id="101" name="Rectangle 100">
+            <a:extLst>
+              <a:ext uri="{FF2B5EF4-FFF2-40B4-BE49-F238E27FC236}">
+                <a16:creationId xmlns:a16="http://schemas.microsoft.com/office/drawing/2014/main" id="{E3FDF41E-8AEF-1E32-5775-129E4BF93F25}"/>
+              </a:ext>
+            </a:extLst>
+          </p:cNvPr>
+          <p:cNvSpPr/>
+          <p:nvPr/>
+        </p:nvSpPr>
+        <p:spPr>
+          <a:xfrm>
+            <a:off x="435091" y="3810839"/>
+            <a:ext cx="1034613" cy="299385"/>
+          </a:xfrm>
+          <a:prstGeom prst="rect">
+            <a:avLst/>
+          </a:prstGeom>
+          <a:solidFill>
+            <a:schemeClr val="tx1">
+              <a:lumMod val="85000"/>
+              <a:lumOff val="15000"/>
+              <a:alpha val="51079"/>
+            </a:schemeClr>
+          </a:solidFill>
+          <a:ln>
+            <a:solidFill>
+              <a:srgbClr val="000000"/>
+            </a:solidFill>
+          </a:ln>
+        </p:spPr>
+        <p:style>
+          <a:lnRef idx="1">
+            <a:schemeClr val="accent6"/>
+          </a:lnRef>
+          <a:fillRef idx="3">
+            <a:schemeClr val="accent6"/>
+          </a:fillRef>
+          <a:effectRef idx="2">
+            <a:schemeClr val="accent6"/>
+          </a:effectRef>
+          <a:fontRef idx="minor">
+            <a:schemeClr val="lt1"/>
+          </a:fontRef>
+        </p:style>
+        <p:txBody>
+          <a:bodyPr rtlCol="0" anchor="ctr"/>
+          <a:lstStyle/>
+          <a:p>
+            <a:pPr algn="ctr"/>
+            <a:r>
+              <a:rPr lang="en-US"/>
+              <a:t>history</a:t>
+            </a:r>
+          </a:p>
+        </p:txBody>
+      </p:sp>
+      <p:sp>
+        <p:nvSpPr>
+          <p:cNvPr id="102" name="Rectangle 101">
+            <a:extLst>
+              <a:ext uri="{FF2B5EF4-FFF2-40B4-BE49-F238E27FC236}">
+                <a16:creationId xmlns:a16="http://schemas.microsoft.com/office/drawing/2014/main" id="{46F84E33-0A55-9F9C-5A8F-F6AFBFBD83AF}"/>
+              </a:ext>
+            </a:extLst>
+          </p:cNvPr>
+          <p:cNvSpPr/>
+          <p:nvPr/>
+        </p:nvSpPr>
+        <p:spPr>
+          <a:xfrm>
+            <a:off x="435091" y="4249416"/>
+            <a:ext cx="1034613" cy="299385"/>
+          </a:xfrm>
+          <a:prstGeom prst="rect">
+            <a:avLst/>
+          </a:prstGeom>
+          <a:solidFill>
+            <a:schemeClr val="tx1">
+              <a:lumMod val="85000"/>
+              <a:lumOff val="15000"/>
+              <a:alpha val="51079"/>
+            </a:schemeClr>
+          </a:solidFill>
+          <a:ln>
+            <a:solidFill>
+              <a:srgbClr val="000000"/>
+            </a:solidFill>
+          </a:ln>
+        </p:spPr>
+        <p:style>
+          <a:lnRef idx="1">
+            <a:schemeClr val="accent6"/>
+          </a:lnRef>
+          <a:fillRef idx="3">
+            <a:schemeClr val="accent6"/>
+          </a:fillRef>
+          <a:effectRef idx="2">
+            <a:schemeClr val="accent6"/>
+          </a:effectRef>
+          <a:fontRef idx="minor">
+            <a:schemeClr val="lt1"/>
+          </a:fontRef>
+        </p:style>
+        <p:txBody>
+          <a:bodyPr rtlCol="0" anchor="ctr"/>
+          <a:lstStyle/>
+          <a:p>
+            <a:pPr algn="ctr"/>
+            <a:r>
+              <a:rPr lang="en-US"/>
+              <a:t>criteria</a:t>
+            </a:r>
+          </a:p>
+        </p:txBody>
+      </p:sp>
+      <p:sp>
+        <p:nvSpPr>
+          <p:cNvPr id="142" name="Rectangle 141">
+            <a:extLst>
+              <a:ext uri="{FF2B5EF4-FFF2-40B4-BE49-F238E27FC236}">
+                <a16:creationId xmlns:a16="http://schemas.microsoft.com/office/drawing/2014/main" id="{DDD04917-EE8D-F470-E69D-AC98C27FBCCA}"/>
+              </a:ext>
+            </a:extLst>
+          </p:cNvPr>
+          <p:cNvSpPr/>
+          <p:nvPr/>
+        </p:nvSpPr>
+        <p:spPr>
+          <a:xfrm>
+            <a:off x="5975582" y="607702"/>
+            <a:ext cx="3020500" cy="758582"/>
+          </a:xfrm>
+          <a:prstGeom prst="rect">
+            <a:avLst/>
+          </a:prstGeom>
+          <a:noFill/>
+          <a:ln w="3175">
+            <a:solidFill>
+              <a:srgbClr val="000000"/>
+            </a:solidFill>
+          </a:ln>
+        </p:spPr>
+        <p:style>
+          <a:lnRef idx="1">
+            <a:schemeClr val="accent6"/>
+          </a:lnRef>
+          <a:fillRef idx="3">
+            <a:schemeClr val="accent6"/>
+          </a:fillRef>
+          <a:effectRef idx="2">
+            <a:schemeClr val="accent6"/>
+          </a:effectRef>
+          <a:fontRef idx="minor">
+            <a:schemeClr val="lt1"/>
+          </a:fontRef>
+        </p:style>
+        <p:txBody>
+          <a:bodyPr rtlCol="0" anchor="ctr"/>
+          <a:lstStyle/>
+          <a:p>
+            <a:pPr algn="ctr"/>
+            <a:endParaRPr lang="en-US" sz="2400" dirty="0"/>
+          </a:p>
+        </p:txBody>
+      </p:sp>
+      <p:sp>
+        <p:nvSpPr>
+          <p:cNvPr id="103" name="Rectangle 102">
+            <a:extLst>
+              <a:ext uri="{FF2B5EF4-FFF2-40B4-BE49-F238E27FC236}">
+                <a16:creationId xmlns:a16="http://schemas.microsoft.com/office/drawing/2014/main" id="{7C916FDD-FF9A-1B5E-25F2-84AFBA6672F6}"/>
+              </a:ext>
+            </a:extLst>
+          </p:cNvPr>
+          <p:cNvSpPr/>
+          <p:nvPr/>
+        </p:nvSpPr>
+        <p:spPr>
+          <a:xfrm>
+            <a:off x="435090" y="4694617"/>
+            <a:ext cx="1034613" cy="299385"/>
+          </a:xfrm>
+          <a:prstGeom prst="rect">
+            <a:avLst/>
+          </a:prstGeom>
+          <a:solidFill>
+            <a:schemeClr val="tx1">
+              <a:lumMod val="85000"/>
+              <a:lumOff val="15000"/>
+              <a:alpha val="51079"/>
+            </a:schemeClr>
+          </a:solidFill>
+          <a:ln>
+            <a:solidFill>
+              <a:srgbClr val="000000"/>
+            </a:solidFill>
+          </a:ln>
+        </p:spPr>
+        <p:style>
+          <a:lnRef idx="1">
+            <a:schemeClr val="accent6"/>
+          </a:lnRef>
+          <a:fillRef idx="3">
+            <a:schemeClr val="accent6"/>
+          </a:fillRef>
+          <a:effectRef idx="2">
+            <a:schemeClr val="accent6"/>
+          </a:effectRef>
+          <a:fontRef idx="minor">
+            <a:schemeClr val="lt1"/>
+          </a:fontRef>
+        </p:style>
+        <p:txBody>
+          <a:bodyPr rtlCol="0" anchor="ctr"/>
+          <a:lstStyle/>
+          <a:p>
+            <a:pPr algn="ctr"/>
+            <a:r>
+              <a:rPr lang="en-US"/>
+              <a:t>images</a:t>
+            </a:r>
+          </a:p>
+        </p:txBody>
+      </p:sp>
+      <p:grpSp>
+        <p:nvGrpSpPr>
+          <p:cNvPr id="147" name="Group 146">
+            <a:extLst>
+              <a:ext uri="{FF2B5EF4-FFF2-40B4-BE49-F238E27FC236}">
+                <a16:creationId xmlns:a16="http://schemas.microsoft.com/office/drawing/2014/main" id="{2AA838CA-AC1C-70EC-4712-6B9B22ABDE96}"/>
+              </a:ext>
+            </a:extLst>
+          </p:cNvPr>
+          <p:cNvGrpSpPr/>
+          <p:nvPr/>
+        </p:nvGrpSpPr>
+        <p:grpSpPr>
+          <a:xfrm>
+            <a:off x="7226612" y="1569791"/>
+            <a:ext cx="615714" cy="615714"/>
+            <a:chOff x="7204216" y="1488035"/>
+            <a:chExt cx="615714" cy="615714"/>
+          </a:xfrm>
+        </p:grpSpPr>
+        <p:pic>
+          <p:nvPicPr>
+            <p:cNvPr id="141" name="Picture 140" descr="A black background with a black square&#10;&#10;AI-generated content may be incorrect.">
+              <a:extLst>
+                <a:ext uri="{FF2B5EF4-FFF2-40B4-BE49-F238E27FC236}">
+                  <a16:creationId xmlns:a16="http://schemas.microsoft.com/office/drawing/2014/main" id="{2CE0FDB5-C599-5567-D3C6-FD2F09305E09}"/>
+                </a:ext>
+              </a:extLst>
+            </p:cNvPr>
+            <p:cNvPicPr>
+              <a:picLocks noChangeAspect="1"/>
+            </p:cNvPicPr>
+            <p:nvPr/>
+          </p:nvPicPr>
+          <p:blipFill>
+            <a:blip r:embed="rId7"/>
+            <a:stretch>
+              <a:fillRect/>
+            </a:stretch>
+          </p:blipFill>
+          <p:spPr>
+            <a:xfrm>
+              <a:off x="7204216" y="1488035"/>
+              <a:ext cx="615714" cy="615714"/>
+            </a:xfrm>
+            <a:prstGeom prst="rect">
+              <a:avLst/>
+            </a:prstGeom>
+          </p:spPr>
+        </p:pic>
+        <p:sp>
+          <p:nvSpPr>
+            <p:cNvPr id="146" name="Oval 145">
+              <a:extLst>
+                <a:ext uri="{FF2B5EF4-FFF2-40B4-BE49-F238E27FC236}">
+                  <a16:creationId xmlns:a16="http://schemas.microsoft.com/office/drawing/2014/main" id="{03DA8E92-6A43-1D4B-D6FD-713C643B5754}"/>
+                </a:ext>
+              </a:extLst>
+            </p:cNvPr>
+            <p:cNvSpPr/>
+            <p:nvPr/>
+          </p:nvSpPr>
+          <p:spPr>
+            <a:xfrm>
+              <a:off x="7228763" y="1514902"/>
+              <a:ext cx="550223" cy="551665"/>
+            </a:xfrm>
+            <a:prstGeom prst="ellipse">
+              <a:avLst/>
+            </a:prstGeom>
+            <a:noFill/>
+            <a:ln>
+              <a:solidFill>
+                <a:schemeClr val="tx1"/>
+              </a:solidFill>
+            </a:ln>
+          </p:spPr>
+          <p:style>
+            <a:lnRef idx="1">
+              <a:schemeClr val="accent1"/>
+            </a:lnRef>
+            <a:fillRef idx="3">
+              <a:schemeClr val="accent1"/>
+            </a:fillRef>
+            <a:effectRef idx="2">
+              <a:schemeClr val="accent1"/>
+            </a:effectRef>
+            <a:fontRef idx="minor">
+              <a:schemeClr val="lt1"/>
+            </a:fontRef>
+          </p:style>
+          <p:txBody>
+            <a:bodyPr rtlCol="0" anchor="ctr"/>
+            <a:lstStyle/>
+            <a:p>
+              <a:pPr algn="ctr"/>
+              <a:endParaRPr lang="en-US"/>
+            </a:p>
+          </p:txBody>
+        </p:sp>
+      </p:grpSp>
+      <p:cxnSp>
+        <p:nvCxnSpPr>
+          <p:cNvPr id="149" name="Elbow Connector 148">
+            <a:extLst>
+              <a:ext uri="{FF2B5EF4-FFF2-40B4-BE49-F238E27FC236}">
+                <a16:creationId xmlns:a16="http://schemas.microsoft.com/office/drawing/2014/main" id="{5791E704-512C-353F-B6B7-8E436058378C}"/>
+              </a:ext>
+            </a:extLst>
+          </p:cNvPr>
+          <p:cNvCxnSpPr>
+            <a:cxnSpLocks/>
+            <a:stCxn id="130" idx="3"/>
+          </p:cNvCxnSpPr>
+          <p:nvPr/>
+        </p:nvCxnSpPr>
+        <p:spPr>
+          <a:xfrm flipV="1">
+            <a:off x="5335465" y="1007202"/>
+            <a:ext cx="616367" cy="600829"/>
+          </a:xfrm>
+          <a:prstGeom prst="bentConnector3">
+            <a:avLst/>
+          </a:prstGeom>
+          <a:ln>
+            <a:tailEnd type="triangle"/>
+          </a:ln>
+        </p:spPr>
+        <p:style>
+          <a:lnRef idx="2">
+            <a:schemeClr val="dk1"/>
+          </a:lnRef>
+          <a:fillRef idx="0">
+            <a:schemeClr val="dk1"/>
+          </a:fillRef>
+          <a:effectRef idx="1">
+            <a:schemeClr val="dk1"/>
+          </a:effectRef>
+          <a:fontRef idx="minor">
+            <a:schemeClr val="tx1"/>
+          </a:fontRef>
+        </p:style>
+      </p:cxnSp>
+      <p:cxnSp>
+        <p:nvCxnSpPr>
+          <p:cNvPr id="153" name="Elbow Connector 152">
+            <a:extLst>
+              <a:ext uri="{FF2B5EF4-FFF2-40B4-BE49-F238E27FC236}">
+                <a16:creationId xmlns:a16="http://schemas.microsoft.com/office/drawing/2014/main" id="{7483A34A-C789-1C5F-E7AE-4435E698B33F}"/>
+              </a:ext>
+            </a:extLst>
+          </p:cNvPr>
+          <p:cNvCxnSpPr>
+            <a:cxnSpLocks/>
+            <a:stCxn id="130" idx="3"/>
+            <a:endCxn id="141" idx="1"/>
+          </p:cNvCxnSpPr>
+          <p:nvPr/>
+        </p:nvCxnSpPr>
+        <p:spPr>
+          <a:xfrm>
+            <a:off x="5335465" y="1608031"/>
+            <a:ext cx="1891147" cy="269617"/>
+          </a:xfrm>
+          <a:prstGeom prst="bentConnector3">
+            <a:avLst>
+              <a:gd name="adj1" fmla="val 16338"/>
+            </a:avLst>
+          </a:prstGeom>
+          <a:ln>
+            <a:tailEnd type="triangle"/>
+          </a:ln>
+        </p:spPr>
+        <p:style>
+          <a:lnRef idx="2">
+            <a:schemeClr val="dk1"/>
+          </a:lnRef>
+          <a:fillRef idx="0">
+            <a:schemeClr val="dk1"/>
+          </a:fillRef>
+          <a:effectRef idx="1">
+            <a:schemeClr val="dk1"/>
+          </a:effectRef>
+          <a:fontRef idx="minor">
+            <a:schemeClr val="tx1"/>
+          </a:fontRef>
+        </p:style>
+      </p:cxnSp>
+      <p:sp>
+        <p:nvSpPr>
+          <p:cNvPr id="157" name="Rectangle 156">
+            <a:extLst>
+              <a:ext uri="{FF2B5EF4-FFF2-40B4-BE49-F238E27FC236}">
+                <a16:creationId xmlns:a16="http://schemas.microsoft.com/office/drawing/2014/main" id="{CD05CC95-FA0B-A639-C46C-91511619545C}"/>
+              </a:ext>
+            </a:extLst>
+          </p:cNvPr>
+          <p:cNvSpPr/>
+          <p:nvPr/>
+        </p:nvSpPr>
+        <p:spPr>
+          <a:xfrm>
+            <a:off x="3817347" y="2261415"/>
+            <a:ext cx="2602955" cy="4535567"/>
+          </a:xfrm>
+          <a:prstGeom prst="rect">
+            <a:avLst/>
+          </a:prstGeom>
+          <a:noFill/>
+          <a:ln w="12700">
+            <a:solidFill>
+              <a:srgbClr val="000000"/>
+            </a:solidFill>
+          </a:ln>
+        </p:spPr>
+        <p:style>
+          <a:lnRef idx="1">
+            <a:schemeClr val="accent6"/>
+          </a:lnRef>
+          <a:fillRef idx="3">
+            <a:schemeClr val="accent6"/>
+          </a:fillRef>
+          <a:effectRef idx="2">
+            <a:schemeClr val="accent6"/>
+          </a:effectRef>
+          <a:fontRef idx="minor">
+            <a:schemeClr val="lt1"/>
+          </a:fontRef>
+        </p:style>
+        <p:txBody>
+          <a:bodyPr rtlCol="0" anchor="ctr"/>
+          <a:lstStyle/>
+          <a:p>
+            <a:pPr algn="ctr"/>
+            <a:endParaRPr lang="en-US" sz="2400" dirty="0"/>
+          </a:p>
+        </p:txBody>
+      </p:sp>
+    </p:spTree>
+    <p:extLst>
+      <p:ext uri="{BB962C8B-B14F-4D97-AF65-F5344CB8AC3E}">
+        <p14:creationId xmlns:p14="http://schemas.microsoft.com/office/powerpoint/2010/main" val="980374541"/>
+      </p:ext>
+    </p:extLst>
   </p:cSld>
   <p:clrMapOvr>
     <a:masterClrMapping/>
@@ -7510,4 +9631,319 @@
   </a:objectDefaults>
   <a:extraClrSchemeLst/>
 </a:theme>
+</file>
+
+<file path=ppt/theme/theme2.xml><?xml version="1.0" encoding="utf-8"?>
+<a:theme xmlns:a="http://schemas.openxmlformats.org/drawingml/2006/main" name="Office Theme">
+  <a:themeElements>
+    <a:clrScheme name="Office">
+      <a:dk1>
+        <a:sysClr val="windowText" lastClr="000000"/>
+      </a:dk1>
+      <a:lt1>
+        <a:sysClr val="window" lastClr="FFFFFF"/>
+      </a:lt1>
+      <a:dk2>
+        <a:srgbClr val="0E2841"/>
+      </a:dk2>
+      <a:lt2>
+        <a:srgbClr val="E8E8E8"/>
+      </a:lt2>
+      <a:accent1>
+        <a:srgbClr val="156082"/>
+      </a:accent1>
+      <a:accent2>
+        <a:srgbClr val="E97132"/>
+      </a:accent2>
+      <a:accent3>
+        <a:srgbClr val="196B24"/>
+      </a:accent3>
+      <a:accent4>
+        <a:srgbClr val="0F9ED5"/>
+      </a:accent4>
+      <a:accent5>
+        <a:srgbClr val="A02B93"/>
+      </a:accent5>
+      <a:accent6>
+        <a:srgbClr val="4EA72E"/>
+      </a:accent6>
+      <a:hlink>
+        <a:srgbClr val="467886"/>
+      </a:hlink>
+      <a:folHlink>
+        <a:srgbClr val="96607D"/>
+      </a:folHlink>
+    </a:clrScheme>
+    <a:fontScheme name="Office">
+      <a:majorFont>
+        <a:latin typeface="Aptos Display" panose="02110004020202020204"/>
+        <a:ea typeface=""/>
+        <a:cs typeface=""/>
+        <a:font script="Jpan" typeface="游ゴシック Light"/>
+        <a:font script="Hang" typeface="맑은 고딕"/>
+        <a:font script="Hans" typeface="等线 Light"/>
+        <a:font script="Hant" typeface="新細明體"/>
+        <a:font script="Arab" typeface="Times New Roman"/>
+        <a:font script="Hebr" typeface="Times New Roman"/>
+        <a:font script="Thai" typeface="Angsana New"/>
+        <a:font script="Ethi" typeface="Nyala"/>
+        <a:font script="Beng" typeface="Vrinda"/>
+        <a:font script="Gujr" typeface="Shruti"/>
+        <a:font script="Khmr" typeface="MoolBoran"/>
+        <a:font script="Knda" typeface="Tunga"/>
+        <a:font script="Guru" typeface="Raavi"/>
+        <a:font script="Cans" typeface="Euphemia"/>
+        <a:font script="Cher" typeface="Plantagenet Cherokee"/>
+        <a:font script="Yiii" typeface="Microsoft Yi Baiti"/>
+        <a:font script="Tibt" typeface="Microsoft Himalaya"/>
+        <a:font script="Thaa" typeface="MV Boli"/>
+        <a:font script="Deva" typeface="Mangal"/>
+        <a:font script="Telu" typeface="Gautami"/>
+        <a:font script="Taml" typeface="Latha"/>
+        <a:font script="Syrc" typeface="Estrangelo Edessa"/>
+        <a:font script="Orya" typeface="Kalinga"/>
+        <a:font script="Mlym" typeface="Kartika"/>
+        <a:font script="Laoo" typeface="DokChampa"/>
+        <a:font script="Sinh" typeface="Iskoola Pota"/>
+        <a:font script="Mong" typeface="Mongolian Baiti"/>
+        <a:font script="Viet" typeface="Times New Roman"/>
+        <a:font script="Uigh" typeface="Microsoft Uighur"/>
+        <a:font script="Geor" typeface="Sylfaen"/>
+        <a:font script="Armn" typeface="Arial"/>
+        <a:font script="Bugi" typeface="Leelawadee UI"/>
+        <a:font script="Bopo" typeface="Microsoft JhengHei"/>
+        <a:font script="Java" typeface="Javanese Text"/>
+        <a:font script="Lisu" typeface="Segoe UI"/>
+        <a:font script="Mymr" typeface="Myanmar Text"/>
+        <a:font script="Nkoo" typeface="Ebrima"/>
+        <a:font script="Olck" typeface="Nirmala UI"/>
+        <a:font script="Osma" typeface="Ebrima"/>
+        <a:font script="Phag" typeface="Phagspa"/>
+        <a:font script="Syrn" typeface="Estrangelo Edessa"/>
+        <a:font script="Syrj" typeface="Estrangelo Edessa"/>
+        <a:font script="Syre" typeface="Estrangelo Edessa"/>
+        <a:font script="Sora" typeface="Nirmala UI"/>
+        <a:font script="Tale" typeface="Microsoft Tai Le"/>
+        <a:font script="Talu" typeface="Microsoft New Tai Lue"/>
+        <a:font script="Tfng" typeface="Ebrima"/>
+      </a:majorFont>
+      <a:minorFont>
+        <a:latin typeface="Aptos" panose="02110004020202020204"/>
+        <a:ea typeface=""/>
+        <a:cs typeface=""/>
+        <a:font script="Jpan" typeface="游ゴシック"/>
+        <a:font script="Hang" typeface="맑은 고딕"/>
+        <a:font script="Hans" typeface="等线"/>
+        <a:font script="Hant" typeface="新細明體"/>
+        <a:font script="Arab" typeface="Arial"/>
+        <a:font script="Hebr" typeface="Arial"/>
+        <a:font script="Thai" typeface="Cordia New"/>
+        <a:font script="Ethi" typeface="Nyala"/>
+        <a:font script="Beng" typeface="Vrinda"/>
+        <a:font script="Gujr" typeface="Shruti"/>
+        <a:font script="Khmr" typeface="DaunPenh"/>
+        <a:font script="Knda" typeface="Tunga"/>
+        <a:font script="Guru" typeface="Raavi"/>
+        <a:font script="Cans" typeface="Euphemia"/>
+        <a:font script="Cher" typeface="Plantagenet Cherokee"/>
+        <a:font script="Yiii" typeface="Microsoft Yi Baiti"/>
+        <a:font script="Tibt" typeface="Microsoft Himalaya"/>
+        <a:font script="Thaa" typeface="MV Boli"/>
+        <a:font script="Deva" typeface="Mangal"/>
+        <a:font script="Telu" typeface="Gautami"/>
+        <a:font script="Taml" typeface="Latha"/>
+        <a:font script="Syrc" typeface="Estrangelo Edessa"/>
+        <a:font script="Orya" typeface="Kalinga"/>
+        <a:font script="Mlym" typeface="Kartika"/>
+        <a:font script="Laoo" typeface="DokChampa"/>
+        <a:font script="Sinh" typeface="Iskoola Pota"/>
+        <a:font script="Mong" typeface="Mongolian Baiti"/>
+        <a:font script="Viet" typeface="Arial"/>
+        <a:font script="Uigh" typeface="Microsoft Uighur"/>
+        <a:font script="Geor" typeface="Sylfaen"/>
+        <a:font script="Armn" typeface="Arial"/>
+        <a:font script="Bugi" typeface="Leelawadee UI"/>
+        <a:font script="Bopo" typeface="Microsoft JhengHei"/>
+        <a:font script="Java" typeface="Javanese Text"/>
+        <a:font script="Lisu" typeface="Segoe UI"/>
+        <a:font script="Mymr" typeface="Myanmar Text"/>
+        <a:font script="Nkoo" typeface="Ebrima"/>
+        <a:font script="Olck" typeface="Nirmala UI"/>
+        <a:font script="Osma" typeface="Ebrima"/>
+        <a:font script="Phag" typeface="Phagspa"/>
+        <a:font script="Syrn" typeface="Estrangelo Edessa"/>
+        <a:font script="Syrj" typeface="Estrangelo Edessa"/>
+        <a:font script="Syre" typeface="Estrangelo Edessa"/>
+        <a:font script="Sora" typeface="Nirmala UI"/>
+        <a:font script="Tale" typeface="Microsoft Tai Le"/>
+        <a:font script="Talu" typeface="Microsoft New Tai Lue"/>
+        <a:font script="Tfng" typeface="Ebrima"/>
+      </a:minorFont>
+    </a:fontScheme>
+    <a:fmtScheme name="Office">
+      <a:fillStyleLst>
+        <a:solidFill>
+          <a:schemeClr val="phClr"/>
+        </a:solidFill>
+        <a:gradFill rotWithShape="1">
+          <a:gsLst>
+            <a:gs pos="0">
+              <a:schemeClr val="phClr">
+                <a:lumMod val="110000"/>
+                <a:satMod val="105000"/>
+                <a:tint val="67000"/>
+              </a:schemeClr>
+            </a:gs>
+            <a:gs pos="50000">
+              <a:schemeClr val="phClr">
+                <a:lumMod val="105000"/>
+                <a:satMod val="103000"/>
+                <a:tint val="73000"/>
+              </a:schemeClr>
+            </a:gs>
+            <a:gs pos="100000">
+              <a:schemeClr val="phClr">
+                <a:lumMod val="105000"/>
+                <a:satMod val="109000"/>
+                <a:tint val="81000"/>
+              </a:schemeClr>
+            </a:gs>
+          </a:gsLst>
+          <a:lin ang="5400000" scaled="0"/>
+        </a:gradFill>
+        <a:gradFill rotWithShape="1">
+          <a:gsLst>
+            <a:gs pos="0">
+              <a:schemeClr val="phClr">
+                <a:satMod val="103000"/>
+                <a:lumMod val="102000"/>
+                <a:tint val="94000"/>
+              </a:schemeClr>
+            </a:gs>
+            <a:gs pos="50000">
+              <a:schemeClr val="phClr">
+                <a:satMod val="110000"/>
+                <a:lumMod val="100000"/>
+                <a:shade val="100000"/>
+              </a:schemeClr>
+            </a:gs>
+            <a:gs pos="100000">
+              <a:schemeClr val="phClr">
+                <a:lumMod val="99000"/>
+                <a:satMod val="120000"/>
+                <a:shade val="78000"/>
+              </a:schemeClr>
+            </a:gs>
+          </a:gsLst>
+          <a:lin ang="5400000" scaled="0"/>
+        </a:gradFill>
+      </a:fillStyleLst>
+      <a:lnStyleLst>
+        <a:ln w="12700" cap="flat" cmpd="sng" algn="ctr">
+          <a:solidFill>
+            <a:schemeClr val="phClr"/>
+          </a:solidFill>
+          <a:prstDash val="solid"/>
+          <a:miter lim="800000"/>
+        </a:ln>
+        <a:ln w="19050" cap="flat" cmpd="sng" algn="ctr">
+          <a:solidFill>
+            <a:schemeClr val="phClr"/>
+          </a:solidFill>
+          <a:prstDash val="solid"/>
+          <a:miter lim="800000"/>
+        </a:ln>
+        <a:ln w="25400" cap="flat" cmpd="sng" algn="ctr">
+          <a:solidFill>
+            <a:schemeClr val="phClr"/>
+          </a:solidFill>
+          <a:prstDash val="solid"/>
+          <a:miter lim="800000"/>
+        </a:ln>
+      </a:lnStyleLst>
+      <a:effectStyleLst>
+        <a:effectStyle>
+          <a:effectLst/>
+        </a:effectStyle>
+        <a:effectStyle>
+          <a:effectLst/>
+        </a:effectStyle>
+        <a:effectStyle>
+          <a:effectLst>
+            <a:outerShdw blurRad="57150" dist="19050" dir="5400000" algn="ctr" rotWithShape="0">
+              <a:srgbClr val="000000">
+                <a:alpha val="63000"/>
+              </a:srgbClr>
+            </a:outerShdw>
+          </a:effectLst>
+        </a:effectStyle>
+      </a:effectStyleLst>
+      <a:bgFillStyleLst>
+        <a:solidFill>
+          <a:schemeClr val="phClr"/>
+        </a:solidFill>
+        <a:solidFill>
+          <a:schemeClr val="phClr">
+            <a:tint val="95000"/>
+            <a:satMod val="170000"/>
+          </a:schemeClr>
+        </a:solidFill>
+        <a:gradFill rotWithShape="1">
+          <a:gsLst>
+            <a:gs pos="0">
+              <a:schemeClr val="phClr">
+                <a:tint val="93000"/>
+                <a:satMod val="150000"/>
+                <a:shade val="98000"/>
+                <a:lumMod val="102000"/>
+              </a:schemeClr>
+            </a:gs>
+            <a:gs pos="50000">
+              <a:schemeClr val="phClr">
+                <a:tint val="98000"/>
+                <a:satMod val="130000"/>
+                <a:shade val="90000"/>
+                <a:lumMod val="103000"/>
+              </a:schemeClr>
+            </a:gs>
+            <a:gs pos="100000">
+              <a:schemeClr val="phClr">
+                <a:shade val="63000"/>
+                <a:satMod val="120000"/>
+              </a:schemeClr>
+            </a:gs>
+          </a:gsLst>
+          <a:lin ang="5400000" scaled="0"/>
+        </a:gradFill>
+      </a:bgFillStyleLst>
+    </a:fmtScheme>
+  </a:themeElements>
+  <a:objectDefaults>
+    <a:lnDef>
+      <a:spPr/>
+      <a:bodyPr/>
+      <a:lstStyle/>
+      <a:style>
+        <a:lnRef idx="2">
+          <a:schemeClr val="accent1"/>
+        </a:lnRef>
+        <a:fillRef idx="0">
+          <a:schemeClr val="accent1"/>
+        </a:fillRef>
+        <a:effectRef idx="1">
+          <a:schemeClr val="accent1"/>
+        </a:effectRef>
+        <a:fontRef idx="minor">
+          <a:schemeClr val="tx1"/>
+        </a:fontRef>
+      </a:style>
+    </a:lnDef>
+  </a:objectDefaults>
+  <a:extraClrSchemeLst/>
+  <a:extLst>
+    <a:ext uri="{05A4C25C-085E-4340-85A3-A5531E510DB2}">
+      <thm15:themeFamily xmlns:thm15="http://schemas.microsoft.com/office/thememl/2012/main" name="Office Theme" id="{2E142A2C-CD16-42D6-873A-C26D2A0506FA}" vid="{1BDDFF52-6CD6-40A5-AB3C-68EB2F1E4D0A}"/>
+    </a:ext>
+  </a:extLst>
+</a:theme>
 </file>
</xml_diff>